<commit_message>
docs(decks): UAF-owned target architecture framing — CTO can present with pride
</commit_message>
<xml_diff>
--- a/docs/decks/LedgeRX-System-Architecture-CTO-Light.pptx
+++ b/docs/decks/LedgeRX-System-Architecture-CTO-Light.pptx
@@ -3175,79 +3175,9 @@
           </a:p>
         </p:txBody>
       </p:sp>
-      <p:sp>
-        <p:nvSpPr>
-          <p:cNvPr id="4" name="TextBox 3"/>
-          <p:cNvSpPr txBox="1"/>
-          <p:nvPr/>
-        </p:nvSpPr>
-        <p:spPr>
-          <a:xfrm>
-            <a:off x="411480" y="164592"/>
-            <a:ext cx="7315200" cy="256032"/>
-          </a:xfrm>
-          <a:prstGeom prst="rect">
-            <a:avLst/>
-          </a:prstGeom>
-          <a:noFill/>
-        </p:spPr>
-        <p:txBody>
-          <a:bodyPr wrap="square" lIns="25400" rIns="25400" tIns="0" bIns="0">
-            <a:spAutoFit/>
-          </a:bodyPr>
-          <a:lstStyle/>
-          <a:p>
-            <a:pPr algn="l"/>
-            <a:r>
-              <a:rPr sz="2000" b="1">
-                <a:solidFill>
-                  <a:srgbClr val="18181B"/>
-                </a:solidFill>
-                <a:latin typeface="Calibri"/>
-              </a:rPr>
-              <a:t>LedgeRX — System context</a:t>
-            </a:r>
-          </a:p>
-        </p:txBody>
-      </p:sp>
-      <p:sp>
-        <p:nvSpPr>
-          <p:cNvPr id="5" name="TextBox 4"/>
-          <p:cNvSpPr txBox="1"/>
-          <p:nvPr/>
-        </p:nvSpPr>
-        <p:spPr>
-          <a:xfrm>
-            <a:off x="411480" y="438912"/>
-            <a:ext cx="8229600" cy="201168"/>
-          </a:xfrm>
-          <a:prstGeom prst="rect">
-            <a:avLst/>
-          </a:prstGeom>
-          <a:noFill/>
-        </p:spPr>
-        <p:txBody>
-          <a:bodyPr wrap="square" lIns="25400" rIns="25400" tIns="0" bIns="0">
-            <a:spAutoFit/>
-          </a:bodyPr>
-          <a:lstStyle/>
-          <a:p>
-            <a:pPr algn="l"/>
-            <a:r>
-              <a:rPr sz="1100" b="0">
-                <a:solidFill>
-                  <a:srgbClr val="71717A"/>
-                </a:solidFill>
-                <a:latin typeface="Calibri"/>
-              </a:rPr>
-              <a:t>Logical architecture  ·  component edges  ·  integration boundary</a:t>
-            </a:r>
-          </a:p>
-        </p:txBody>
-      </p:sp>
       <p:pic>
         <p:nvPicPr>
-          <p:cNvPr id="6" name="Picture 5" descr="uaf_badge_48.png"/>
+          <p:cNvPr id="4" name="Picture 3" descr="uaf_badge_48.png"/>
           <p:cNvPicPr>
             <a:picLocks noChangeAspect="1"/>
           </p:cNvPicPr>
@@ -3261,14 +3191,84 @@
         </p:blipFill>
         <p:spPr>
           <a:xfrm>
-            <a:off x="9144000" y="182880"/>
-            <a:ext cx="1097280" cy="347472"/>
+            <a:off x="411480" y="146304"/>
+            <a:ext cx="1143000" cy="365760"/>
           </a:xfrm>
           <a:prstGeom prst="rect">
             <a:avLst/>
           </a:prstGeom>
         </p:spPr>
       </p:pic>
+      <p:sp>
+        <p:nvSpPr>
+          <p:cNvPr id="5" name="TextBox 4"/>
+          <p:cNvSpPr txBox="1"/>
+          <p:nvPr/>
+        </p:nvSpPr>
+        <p:spPr>
+          <a:xfrm>
+            <a:off x="1691640" y="146304"/>
+            <a:ext cx="7772400" cy="256032"/>
+          </a:xfrm>
+          <a:prstGeom prst="rect">
+            <a:avLst/>
+          </a:prstGeom>
+          <a:noFill/>
+        </p:spPr>
+        <p:txBody>
+          <a:bodyPr wrap="square" lIns="25400" rIns="25400" tIns="0" bIns="0">
+            <a:spAutoFit/>
+          </a:bodyPr>
+          <a:lstStyle/>
+          <a:p>
+            <a:pPr algn="l"/>
+            <a:r>
+              <a:rPr sz="1800" b="1">
+                <a:solidFill>
+                  <a:srgbClr val="18181B"/>
+                </a:solidFill>
+                <a:latin typeface="Calibri"/>
+              </a:rPr>
+              <a:t>Target architecture  ·  Rewards platform modernization</a:t>
+            </a:r>
+          </a:p>
+        </p:txBody>
+      </p:sp>
+      <p:sp>
+        <p:nvSpPr>
+          <p:cNvPr id="6" name="TextBox 5"/>
+          <p:cNvSpPr txBox="1"/>
+          <p:nvPr/>
+        </p:nvSpPr>
+        <p:spPr>
+          <a:xfrm>
+            <a:off x="1691640" y="420624"/>
+            <a:ext cx="7772400" cy="201168"/>
+          </a:xfrm>
+          <a:prstGeom prst="rect">
+            <a:avLst/>
+          </a:prstGeom>
+          <a:noFill/>
+        </p:spPr>
+        <p:txBody>
+          <a:bodyPr wrap="square" lIns="25400" rIns="25400" tIns="0" bIns="0">
+            <a:spAutoFit/>
+          </a:bodyPr>
+          <a:lstStyle/>
+          <a:p>
+            <a:pPr algn="l"/>
+            <a:r>
+              <a:rPr sz="1100" b="0">
+                <a:solidFill>
+                  <a:srgbClr val="71717A"/>
+                </a:solidFill>
+                <a:latin typeface="Calibri"/>
+              </a:rPr>
+              <a:t>UAF builds the platform  ·  clear domain boundaries  ·  specialized ledger capability in the middle</a:t>
+            </a:r>
+          </a:p>
+        </p:txBody>
+      </p:sp>
       <p:pic>
         <p:nvPicPr>
           <p:cNvPr id="7" name="Picture 6" descr="sim_mark_40.png"/>
@@ -3285,7 +3285,7 @@
         </p:blipFill>
         <p:spPr>
           <a:xfrm>
-            <a:off x="10378440" y="201168"/>
+            <a:off x="10424160" y="182880"/>
             <a:ext cx="329184" cy="329184"/>
           </a:xfrm>
           <a:prstGeom prst="rect">
@@ -3301,7 +3301,7 @@
         </p:nvSpPr>
         <p:spPr>
           <a:xfrm>
-            <a:off x="10789920" y="256032"/>
+            <a:off x="10881360" y="237744"/>
             <a:ext cx="822960" cy="219456"/>
           </a:xfrm>
           <a:prstGeom prst="rect">
@@ -3336,8 +3336,90 @@
         </p:nvSpPr>
         <p:spPr>
           <a:xfrm>
-            <a:off x="411480" y="822960"/>
-            <a:ext cx="1965960" cy="5166360"/>
+            <a:off x="411480" y="731520"/>
+            <a:ext cx="11365992" cy="384048"/>
+          </a:xfrm>
+          <a:prstGeom prst="roundRect">
+            <a:avLst>
+              <a:gd name="adj" fmla="val 3000"/>
+            </a:avLst>
+          </a:prstGeom>
+          <a:solidFill>
+            <a:srgbClr val="EEF2F7"/>
+          </a:solidFill>
+          <a:ln w="12700">
+            <a:solidFill>
+              <a:srgbClr val="D4D4D8"/>
+            </a:solidFill>
+          </a:ln>
+        </p:spPr>
+        <p:style>
+          <a:lnRef idx="1">
+            <a:schemeClr val="accent1"/>
+          </a:lnRef>
+          <a:fillRef idx="3">
+            <a:schemeClr val="accent1"/>
+          </a:fillRef>
+          <a:effectRef idx="2">
+            <a:schemeClr val="accent1"/>
+          </a:effectRef>
+          <a:fontRef idx="minor">
+            <a:schemeClr val="lt1"/>
+          </a:fontRef>
+        </p:style>
+        <p:txBody>
+          <a:bodyPr rtlCol="0" anchor="ctr"/>
+          <a:lstStyle/>
+          <a:p>
+            <a:pPr algn="ctr"/>
+          </a:p>
+        </p:txBody>
+      </p:sp>
+      <p:sp>
+        <p:nvSpPr>
+          <p:cNvPr id="10" name="TextBox 9"/>
+          <p:cNvSpPr txBox="1"/>
+          <p:nvPr/>
+        </p:nvSpPr>
+        <p:spPr>
+          <a:xfrm>
+            <a:off x="548640" y="804672"/>
+            <a:ext cx="11064240" cy="256032"/>
+          </a:xfrm>
+          <a:prstGeom prst="rect">
+            <a:avLst/>
+          </a:prstGeom>
+          <a:noFill/>
+        </p:spPr>
+        <p:txBody>
+          <a:bodyPr wrap="square" lIns="25400" rIns="25400" tIns="0" bIns="0">
+            <a:spAutoFit/>
+          </a:bodyPr>
+          <a:lstStyle/>
+          <a:p>
+            <a:pPr algn="l"/>
+            <a:r>
+              <a:rPr sz="1100" b="0">
+                <a:solidFill>
+                  <a:srgbClr val="1E3A5F"/>
+                </a:solidFill>
+                <a:latin typeface="Calibri"/>
+              </a:rPr>
+              <a:t>Design principle: separate channel systems · integration fabric · reward ledger capability · UAF orchestration · fulfillment systems</a:t>
+            </a:r>
+          </a:p>
+        </p:txBody>
+      </p:sp>
+      <p:sp>
+        <p:nvSpPr>
+          <p:cNvPr id="11" name="Rounded Rectangle 10"/>
+          <p:cNvSpPr/>
+          <p:nvPr/>
+        </p:nvSpPr>
+        <p:spPr>
+          <a:xfrm>
+            <a:off x="411480" y="1280160"/>
+            <a:ext cx="2011680" cy="4709160"/>
           </a:xfrm>
           <a:prstGeom prst="roundRect">
             <a:avLst>
@@ -3377,14 +3459,14 @@
       </p:sp>
       <p:sp>
         <p:nvSpPr>
-          <p:cNvPr id="10" name="Rectangle 9"/>
+          <p:cNvPr id="12" name="Rectangle 11"/>
           <p:cNvSpPr/>
           <p:nvPr/>
         </p:nvSpPr>
         <p:spPr>
           <a:xfrm>
-            <a:off x="411480" y="822960"/>
-            <a:ext cx="1965960" cy="329184"/>
+            <a:off x="411480" y="1280160"/>
+            <a:ext cx="2011680" cy="457200"/>
           </a:xfrm>
           <a:prstGeom prst="rect">
             <a:avLst/>
@@ -3422,14 +3504,14 @@
       </p:sp>
       <p:sp>
         <p:nvSpPr>
-          <p:cNvPr id="11" name="TextBox 10"/>
+          <p:cNvPr id="13" name="TextBox 12"/>
           <p:cNvSpPr txBox="1"/>
           <p:nvPr/>
         </p:nvSpPr>
         <p:spPr>
           <a:xfrm>
-            <a:off x="502920" y="896112"/>
-            <a:ext cx="1783080" cy="219456"/>
+            <a:off x="502920" y="1335024"/>
+            <a:ext cx="1828800" cy="201168"/>
           </a:xfrm>
           <a:prstGeom prst="rect">
             <a:avLst/>
@@ -3450,21 +3532,56 @@
                 </a:solidFill>
                 <a:latin typeface="Calibri"/>
               </a:rPr>
-              <a:t>1  Upstream systems</a:t>
-            </a:r>
-          </a:p>
-        </p:txBody>
-      </p:sp>
-      <p:sp>
-        <p:nvSpPr>
-          <p:cNvPr id="12" name="Rounded Rectangle 11"/>
+              <a:t>A  Channel systems</a:t>
+            </a:r>
+          </a:p>
+        </p:txBody>
+      </p:sp>
+      <p:sp>
+        <p:nvSpPr>
+          <p:cNvPr id="14" name="TextBox 13"/>
+          <p:cNvSpPr txBox="1"/>
+          <p:nvPr/>
+        </p:nvSpPr>
+        <p:spPr>
+          <a:xfrm>
+            <a:off x="502920" y="1536192"/>
+            <a:ext cx="1828800" cy="164592"/>
+          </a:xfrm>
+          <a:prstGeom prst="rect">
+            <a:avLst/>
+          </a:prstGeom>
+          <a:noFill/>
+        </p:spPr>
+        <p:txBody>
+          <a:bodyPr wrap="square" lIns="25400" rIns="25400" tIns="0" bIns="0">
+            <a:spAutoFit/>
+          </a:bodyPr>
+          <a:lstStyle/>
+          <a:p>
+            <a:pPr algn="l"/>
+            <a:r>
+              <a:rPr sz="900" b="0">
+                <a:solidFill>
+                  <a:srgbClr val="71717A"/>
+                </a:solidFill>
+                <a:latin typeface="Calibri"/>
+              </a:rPr>
+              <a:t>Existing UAF estate</a:t>
+            </a:r>
+          </a:p>
+        </p:txBody>
+      </p:sp>
+      <p:sp>
+        <p:nvSpPr>
+          <p:cNvPr id="15" name="Rounded Rectangle 14"/>
           <p:cNvSpPr/>
           <p:nvPr/>
         </p:nvSpPr>
         <p:spPr>
           <a:xfrm>
-            <a:off x="2606040" y="822960"/>
-            <a:ext cx="1965960" cy="5166360"/>
+            <a:off x="2606040" y="1280160"/>
+            <a:ext cx="1965960" cy="4709160"/>
           </a:xfrm>
           <a:prstGeom prst="roundRect">
             <a:avLst>
@@ -3504,14 +3621,14 @@
       </p:sp>
       <p:sp>
         <p:nvSpPr>
-          <p:cNvPr id="13" name="Rectangle 12"/>
+          <p:cNvPr id="16" name="Rectangle 15"/>
           <p:cNvSpPr/>
           <p:nvPr/>
         </p:nvSpPr>
         <p:spPr>
           <a:xfrm>
-            <a:off x="2606040" y="822960"/>
-            <a:ext cx="1965960" cy="329184"/>
+            <a:off x="2606040" y="1280160"/>
+            <a:ext cx="1965960" cy="457200"/>
           </a:xfrm>
           <a:prstGeom prst="rect">
             <a:avLst/>
@@ -3549,14 +3666,14 @@
       </p:sp>
       <p:sp>
         <p:nvSpPr>
-          <p:cNvPr id="14" name="TextBox 13"/>
+          <p:cNvPr id="17" name="TextBox 16"/>
           <p:cNvSpPr txBox="1"/>
           <p:nvPr/>
         </p:nvSpPr>
         <p:spPr>
           <a:xfrm>
-            <a:off x="2697480" y="896112"/>
-            <a:ext cx="1783080" cy="219456"/>
+            <a:off x="2697480" y="1335024"/>
+            <a:ext cx="1783080" cy="201168"/>
           </a:xfrm>
           <a:prstGeom prst="rect">
             <a:avLst/>
@@ -3577,21 +3694,56 @@
                 </a:solidFill>
                 <a:latin typeface="Calibri"/>
               </a:rPr>
-              <a:t>2  Integration</a:t>
-            </a:r>
-          </a:p>
-        </p:txBody>
-      </p:sp>
-      <p:sp>
-        <p:nvSpPr>
-          <p:cNvPr id="15" name="Rounded Rectangle 14"/>
+              <a:t>B  Integration fabric</a:t>
+            </a:r>
+          </a:p>
+        </p:txBody>
+      </p:sp>
+      <p:sp>
+        <p:nvSpPr>
+          <p:cNvPr id="18" name="TextBox 17"/>
+          <p:cNvSpPr txBox="1"/>
+          <p:nvPr/>
+        </p:nvSpPr>
+        <p:spPr>
+          <a:xfrm>
+            <a:off x="2697480" y="1536192"/>
+            <a:ext cx="1783080" cy="164592"/>
+          </a:xfrm>
+          <a:prstGeom prst="rect">
+            <a:avLst/>
+          </a:prstGeom>
+          <a:noFill/>
+        </p:spPr>
+        <p:txBody>
+          <a:bodyPr wrap="square" lIns="25400" rIns="25400" tIns="0" bIns="0">
+            <a:spAutoFit/>
+          </a:bodyPr>
+          <a:lstStyle/>
+          <a:p>
+            <a:pPr algn="l"/>
+            <a:r>
+              <a:rPr sz="900" b="0">
+                <a:solidFill>
+                  <a:srgbClr val="71717A"/>
+                </a:solidFill>
+                <a:latin typeface="Calibri"/>
+              </a:rPr>
+              <a:t>How we connect</a:t>
+            </a:r>
+          </a:p>
+        </p:txBody>
+      </p:sp>
+      <p:sp>
+        <p:nvSpPr>
+          <p:cNvPr id="19" name="Rounded Rectangle 18"/>
           <p:cNvSpPr/>
           <p:nvPr/>
         </p:nvSpPr>
         <p:spPr>
           <a:xfrm>
-            <a:off x="4800600" y="822960"/>
-            <a:ext cx="3657600" cy="5166360"/>
+            <a:off x="4754880" y="1280160"/>
+            <a:ext cx="3520440" cy="4709160"/>
           </a:xfrm>
           <a:prstGeom prst="roundRect">
             <a:avLst>
@@ -3631,14 +3783,14 @@
       </p:sp>
       <p:sp>
         <p:nvSpPr>
-          <p:cNvPr id="16" name="Rectangle 15"/>
+          <p:cNvPr id="20" name="Rectangle 19"/>
           <p:cNvSpPr/>
           <p:nvPr/>
         </p:nvSpPr>
         <p:spPr>
           <a:xfrm>
-            <a:off x="4800600" y="822960"/>
-            <a:ext cx="3657600" cy="329184"/>
+            <a:off x="4754880" y="1280160"/>
+            <a:ext cx="3520440" cy="457200"/>
           </a:xfrm>
           <a:prstGeom prst="rect">
             <a:avLst/>
@@ -3676,14 +3828,14 @@
       </p:sp>
       <p:sp>
         <p:nvSpPr>
-          <p:cNvPr id="17" name="TextBox 16"/>
+          <p:cNvPr id="21" name="TextBox 20"/>
           <p:cNvSpPr txBox="1"/>
           <p:nvPr/>
         </p:nvSpPr>
         <p:spPr>
           <a:xfrm>
-            <a:off x="4892040" y="896112"/>
-            <a:ext cx="3474720" cy="219456"/>
+            <a:off x="4846320" y="1335024"/>
+            <a:ext cx="3337560" cy="201168"/>
           </a:xfrm>
           <a:prstGeom prst="rect">
             <a:avLst/>
@@ -3704,21 +3856,56 @@
                 </a:solidFill>
                 <a:latin typeface="Calibri"/>
               </a:rPr>
-              <a:t>3  LedgeRX (core)</a:t>
-            </a:r>
-          </a:p>
-        </p:txBody>
-      </p:sp>
-      <p:sp>
-        <p:nvSpPr>
-          <p:cNvPr id="18" name="Rounded Rectangle 17"/>
+              <a:t>C  Reward ledger capability</a:t>
+            </a:r>
+          </a:p>
+        </p:txBody>
+      </p:sp>
+      <p:sp>
+        <p:nvSpPr>
+          <p:cNvPr id="22" name="TextBox 21"/>
+          <p:cNvSpPr txBox="1"/>
+          <p:nvPr/>
+        </p:nvSpPr>
+        <p:spPr>
+          <a:xfrm>
+            <a:off x="4846320" y="1536192"/>
+            <a:ext cx="3337560" cy="164592"/>
+          </a:xfrm>
+          <a:prstGeom prst="rect">
+            <a:avLst/>
+          </a:prstGeom>
+          <a:noFill/>
+        </p:spPr>
+        <p:txBody>
+          <a:bodyPr wrap="square" lIns="25400" rIns="25400" tIns="0" bIns="0">
+            <a:spAutoFit/>
+          </a:bodyPr>
+          <a:lstStyle/>
+          <a:p>
+            <a:pPr algn="l"/>
+            <a:r>
+              <a:rPr sz="900" b="0">
+                <a:solidFill>
+                  <a:srgbClr val="71717A"/>
+                </a:solidFill>
+                <a:latin typeface="Calibri"/>
+              </a:rPr>
+              <a:t>New core domain</a:t>
+            </a:r>
+          </a:p>
+        </p:txBody>
+      </p:sp>
+      <p:sp>
+        <p:nvSpPr>
+          <p:cNvPr id="23" name="Rounded Rectangle 22"/>
           <p:cNvSpPr/>
           <p:nvPr/>
         </p:nvSpPr>
         <p:spPr>
           <a:xfrm>
-            <a:off x="8641080" y="822960"/>
-            <a:ext cx="1417320" cy="5166360"/>
+            <a:off x="8458200" y="1280160"/>
+            <a:ext cx="1417320" cy="4709160"/>
           </a:xfrm>
           <a:prstGeom prst="roundRect">
             <a:avLst>
@@ -3758,14 +3945,14 @@
       </p:sp>
       <p:sp>
         <p:nvSpPr>
-          <p:cNvPr id="19" name="Rectangle 18"/>
+          <p:cNvPr id="24" name="Rectangle 23"/>
           <p:cNvSpPr/>
           <p:nvPr/>
         </p:nvSpPr>
         <p:spPr>
           <a:xfrm>
-            <a:off x="8641080" y="822960"/>
-            <a:ext cx="1417320" cy="329184"/>
+            <a:off x="8458200" y="1280160"/>
+            <a:ext cx="1417320" cy="457200"/>
           </a:xfrm>
           <a:prstGeom prst="rect">
             <a:avLst/>
@@ -3803,14 +3990,14 @@
       </p:sp>
       <p:sp>
         <p:nvSpPr>
-          <p:cNvPr id="20" name="TextBox 19"/>
+          <p:cNvPr id="25" name="TextBox 24"/>
           <p:cNvSpPr txBox="1"/>
           <p:nvPr/>
         </p:nvSpPr>
         <p:spPr>
           <a:xfrm>
-            <a:off x="8732520" y="896112"/>
-            <a:ext cx="1234440" cy="219456"/>
+            <a:off x="8549640" y="1335024"/>
+            <a:ext cx="1234440" cy="201168"/>
           </a:xfrm>
           <a:prstGeom prst="rect">
             <a:avLst/>
@@ -3831,21 +4018,56 @@
                 </a:solidFill>
                 <a:latin typeface="Calibri"/>
               </a:rPr>
-              <a:t>5  Extensions</a:t>
-            </a:r>
-          </a:p>
-        </p:txBody>
-      </p:sp>
-      <p:sp>
-        <p:nvSpPr>
-          <p:cNvPr id="21" name="Rounded Rectangle 20"/>
+              <a:t>D  Platform add-ons</a:t>
+            </a:r>
+          </a:p>
+        </p:txBody>
+      </p:sp>
+      <p:sp>
+        <p:nvSpPr>
+          <p:cNvPr id="26" name="TextBox 25"/>
+          <p:cNvSpPr txBox="1"/>
+          <p:nvPr/>
+        </p:nvSpPr>
+        <p:spPr>
+          <a:xfrm>
+            <a:off x="8549640" y="1536192"/>
+            <a:ext cx="1234440" cy="164592"/>
+          </a:xfrm>
+          <a:prstGeom prst="rect">
+            <a:avLst/>
+          </a:prstGeom>
+          <a:noFill/>
+        </p:spPr>
+        <p:txBody>
+          <a:bodyPr wrap="square" lIns="25400" rIns="25400" tIns="0" bIns="0">
+            <a:spAutoFit/>
+          </a:bodyPr>
+          <a:lstStyle/>
+          <a:p>
+            <a:pPr algn="l"/>
+            <a:r>
+              <a:rPr sz="900" b="0">
+                <a:solidFill>
+                  <a:srgbClr val="71717A"/>
+                </a:solidFill>
+                <a:latin typeface="Calibri"/>
+              </a:rPr>
+              <a:t>Evolve later</a:t>
+            </a:r>
+          </a:p>
+        </p:txBody>
+      </p:sp>
+      <p:sp>
+        <p:nvSpPr>
+          <p:cNvPr id="27" name="Rounded Rectangle 26"/>
           <p:cNvSpPr/>
           <p:nvPr/>
         </p:nvSpPr>
         <p:spPr>
           <a:xfrm>
-            <a:off x="10241280" y="822960"/>
-            <a:ext cx="1554480" cy="5166360"/>
+            <a:off x="10058400" y="1280160"/>
+            <a:ext cx="1737360" cy="4709160"/>
           </a:xfrm>
           <a:prstGeom prst="roundRect">
             <a:avLst>
@@ -3885,14 +4107,14 @@
       </p:sp>
       <p:sp>
         <p:nvSpPr>
-          <p:cNvPr id="22" name="Rectangle 21"/>
+          <p:cNvPr id="28" name="Rectangle 27"/>
           <p:cNvSpPr/>
           <p:nvPr/>
         </p:nvSpPr>
         <p:spPr>
           <a:xfrm>
-            <a:off x="10241280" y="822960"/>
-            <a:ext cx="1554480" cy="329184"/>
+            <a:off x="10058400" y="1280160"/>
+            <a:ext cx="1737360" cy="457200"/>
           </a:xfrm>
           <a:prstGeom prst="rect">
             <a:avLst/>
@@ -3930,14 +4152,14 @@
       </p:sp>
       <p:sp>
         <p:nvSpPr>
-          <p:cNvPr id="23" name="TextBox 22"/>
+          <p:cNvPr id="29" name="TextBox 28"/>
           <p:cNvSpPr txBox="1"/>
           <p:nvPr/>
         </p:nvSpPr>
         <p:spPr>
           <a:xfrm>
-            <a:off x="10332720" y="896112"/>
-            <a:ext cx="1371600" cy="219456"/>
+            <a:off x="10149840" y="1335024"/>
+            <a:ext cx="1554480" cy="201168"/>
           </a:xfrm>
           <a:prstGeom prst="rect">
             <a:avLst/>
@@ -3958,21 +4180,56 @@
                 </a:solidFill>
                 <a:latin typeface="Calibri"/>
               </a:rPr>
-              <a:t>4  Downstream</a:t>
-            </a:r>
-          </a:p>
-        </p:txBody>
-      </p:sp>
-      <p:sp>
-        <p:nvSpPr>
-          <p:cNvPr id="24" name="Right Arrow 23"/>
+              <a:t>E  Fulfillment estate</a:t>
+            </a:r>
+          </a:p>
+        </p:txBody>
+      </p:sp>
+      <p:sp>
+        <p:nvSpPr>
+          <p:cNvPr id="30" name="TextBox 29"/>
+          <p:cNvSpPr txBox="1"/>
+          <p:nvPr/>
+        </p:nvSpPr>
+        <p:spPr>
+          <a:xfrm>
+            <a:off x="10149840" y="1536192"/>
+            <a:ext cx="1554480" cy="164592"/>
+          </a:xfrm>
+          <a:prstGeom prst="rect">
+            <a:avLst/>
+          </a:prstGeom>
+          <a:noFill/>
+        </p:spPr>
+        <p:txBody>
+          <a:bodyPr wrap="square" lIns="25400" rIns="25400" tIns="0" bIns="0">
+            <a:spAutoFit/>
+          </a:bodyPr>
+          <a:lstStyle/>
+          <a:p>
+            <a:pPr algn="l"/>
+            <a:r>
+              <a:rPr sz="900" b="0">
+                <a:solidFill>
+                  <a:srgbClr val="71717A"/>
+                </a:solidFill>
+                <a:latin typeface="Calibri"/>
+              </a:rPr>
+              <a:t>Existing + CBP</a:t>
+            </a:r>
+          </a:p>
+        </p:txBody>
+      </p:sp>
+      <p:sp>
+        <p:nvSpPr>
+          <p:cNvPr id="31" name="Right Arrow 30"/>
           <p:cNvSpPr/>
           <p:nvPr/>
         </p:nvSpPr>
         <p:spPr>
           <a:xfrm>
-            <a:off x="2423160" y="2743200"/>
-            <a:ext cx="164592" cy="109728"/>
+            <a:off x="2450592" y="3108960"/>
+            <a:ext cx="146304" cy="100584"/>
           </a:xfrm>
           <a:prstGeom prst="rightArrow">
             <a:avLst/>
@@ -4008,14 +4265,14 @@
       </p:sp>
       <p:sp>
         <p:nvSpPr>
-          <p:cNvPr id="25" name="Right Arrow 24"/>
+          <p:cNvPr id="32" name="Right Arrow 31"/>
           <p:cNvSpPr/>
           <p:nvPr/>
         </p:nvSpPr>
         <p:spPr>
           <a:xfrm>
-            <a:off x="4617720" y="2743200"/>
-            <a:ext cx="164592" cy="109728"/>
+            <a:off x="4599432" y="3108960"/>
+            <a:ext cx="146304" cy="100584"/>
           </a:xfrm>
           <a:prstGeom prst="rightArrow">
             <a:avLst/>
@@ -4051,14 +4308,14 @@
       </p:sp>
       <p:sp>
         <p:nvSpPr>
-          <p:cNvPr id="26" name="Right Arrow 25"/>
+          <p:cNvPr id="33" name="Right Arrow 32"/>
           <p:cNvSpPr/>
           <p:nvPr/>
         </p:nvSpPr>
         <p:spPr>
           <a:xfrm>
-            <a:off x="8476488" y="2743200"/>
-            <a:ext cx="164592" cy="109728"/>
+            <a:off x="8302752" y="3108960"/>
+            <a:ext cx="146304" cy="100584"/>
           </a:xfrm>
           <a:prstGeom prst="rightArrow">
             <a:avLst/>
@@ -4094,14 +4351,14 @@
       </p:sp>
       <p:sp>
         <p:nvSpPr>
-          <p:cNvPr id="27" name="Right Arrow 26"/>
+          <p:cNvPr id="34" name="Right Arrow 33"/>
           <p:cNvSpPr/>
           <p:nvPr/>
         </p:nvSpPr>
         <p:spPr>
           <a:xfrm>
-            <a:off x="10076688" y="2743200"/>
-            <a:ext cx="164592" cy="109728"/>
+            <a:off x="9902952" y="3108960"/>
+            <a:ext cx="146304" cy="100584"/>
           </a:xfrm>
           <a:prstGeom prst="rightArrow">
             <a:avLst/>
@@ -4137,14 +4394,14 @@
       </p:sp>
       <p:sp>
         <p:nvSpPr>
-          <p:cNvPr id="28" name="Right Arrow 27"/>
+          <p:cNvPr id="35" name="Right Arrow 34"/>
           <p:cNvSpPr/>
           <p:nvPr/>
         </p:nvSpPr>
         <p:spPr>
           <a:xfrm>
-            <a:off x="2423160" y="4023360"/>
-            <a:ext cx="164592" cy="109728"/>
+            <a:off x="2450592" y="4297680"/>
+            <a:ext cx="146304" cy="100584"/>
           </a:xfrm>
           <a:prstGeom prst="rightArrow">
             <a:avLst/>
@@ -4180,14 +4437,14 @@
       </p:sp>
       <p:sp>
         <p:nvSpPr>
-          <p:cNvPr id="29" name="Right Arrow 28"/>
+          <p:cNvPr id="36" name="Right Arrow 35"/>
           <p:cNvSpPr/>
           <p:nvPr/>
         </p:nvSpPr>
         <p:spPr>
           <a:xfrm>
-            <a:off x="4617720" y="4023360"/>
-            <a:ext cx="164592" cy="109728"/>
+            <a:off x="4599432" y="4297680"/>
+            <a:ext cx="146304" cy="100584"/>
           </a:xfrm>
           <a:prstGeom prst="rightArrow">
             <a:avLst/>
@@ -4223,14 +4480,14 @@
       </p:sp>
       <p:sp>
         <p:nvSpPr>
-          <p:cNvPr id="30" name="Right Arrow 29"/>
+          <p:cNvPr id="37" name="Right Arrow 36"/>
           <p:cNvSpPr/>
           <p:nvPr/>
         </p:nvSpPr>
         <p:spPr>
           <a:xfrm>
-            <a:off x="8476488" y="4023360"/>
-            <a:ext cx="164592" cy="109728"/>
+            <a:off x="8302752" y="4297680"/>
+            <a:ext cx="146304" cy="100584"/>
           </a:xfrm>
           <a:prstGeom prst="rightArrow">
             <a:avLst/>
@@ -4266,14 +4523,14 @@
       </p:sp>
       <p:sp>
         <p:nvSpPr>
-          <p:cNvPr id="31" name="Right Arrow 30"/>
+          <p:cNvPr id="38" name="Right Arrow 37"/>
           <p:cNvSpPr/>
           <p:nvPr/>
         </p:nvSpPr>
         <p:spPr>
           <a:xfrm>
-            <a:off x="10076688" y="4023360"/>
-            <a:ext cx="164592" cy="109728"/>
+            <a:off x="9902952" y="4297680"/>
+            <a:ext cx="146304" cy="100584"/>
           </a:xfrm>
           <a:prstGeom prst="rightArrow">
             <a:avLst/>
@@ -4307,79 +4564,20 @@
           </a:p>
         </p:txBody>
       </p:sp>
-      <p:pic>
-        <p:nvPicPr>
-          <p:cNvPr id="32" name="Picture 31" descr="uaf_mark_32.png"/>
-          <p:cNvPicPr>
-            <a:picLocks noChangeAspect="1"/>
-          </p:cNvPicPr>
-          <p:nvPr/>
-        </p:nvPicPr>
-        <p:blipFill>
-          <a:blip r:embed="rId4"/>
-          <a:stretch>
-            <a:fillRect/>
-          </a:stretch>
-        </p:blipFill>
-        <p:spPr>
-          <a:xfrm>
-            <a:off x="521208" y="1261872"/>
-            <a:ext cx="256032" cy="256032"/>
-          </a:xfrm>
-          <a:prstGeom prst="rect">
-            <a:avLst/>
-          </a:prstGeom>
-        </p:spPr>
-      </p:pic>
-      <p:sp>
-        <p:nvSpPr>
-          <p:cNvPr id="33" name="TextBox 32"/>
-          <p:cNvSpPr txBox="1"/>
-          <p:nvPr/>
-        </p:nvSpPr>
-        <p:spPr>
-          <a:xfrm>
-            <a:off x="813816" y="1280160"/>
-            <a:ext cx="1463040" cy="219456"/>
-          </a:xfrm>
-          <a:prstGeom prst="rect">
-            <a:avLst/>
-          </a:prstGeom>
-          <a:noFill/>
-        </p:spPr>
-        <p:txBody>
-          <a:bodyPr wrap="square" lIns="25400" rIns="25400" tIns="0" bIns="0">
-            <a:spAutoFit/>
-          </a:bodyPr>
-          <a:lstStyle/>
-          <a:p>
-            <a:pPr algn="l"/>
-            <a:r>
-              <a:rPr sz="1000" b="0">
-                <a:solidFill>
-                  <a:srgbClr val="71717A"/>
-                </a:solidFill>
-                <a:latin typeface="Calibri"/>
-              </a:rPr>
-              <a:t>UAF domain systems</a:t>
-            </a:r>
-          </a:p>
-        </p:txBody>
-      </p:sp>
-      <p:sp>
-        <p:nvSpPr>
-          <p:cNvPr id="34" name="Rounded Rectangle 33"/>
+      <p:sp>
+        <p:nvSpPr>
+          <p:cNvPr id="39" name="Rounded Rectangle 38"/>
           <p:cNvSpPr/>
           <p:nvPr/>
         </p:nvSpPr>
         <p:spPr>
           <a:xfrm>
-            <a:off x="502920" y="1691640"/>
-            <a:ext cx="1783080" cy="914400"/>
+            <a:off x="502920" y="1874520"/>
+            <a:ext cx="1828800" cy="868680"/>
           </a:xfrm>
           <a:prstGeom prst="roundRect">
             <a:avLst>
-              <a:gd name="adj" fmla="val 4000"/>
+              <a:gd name="adj" fmla="val 3000"/>
             </a:avLst>
           </a:prstGeom>
           <a:solidFill>
@@ -4415,14 +4613,14 @@
       </p:sp>
       <p:sp>
         <p:nvSpPr>
-          <p:cNvPr id="35" name="TextBox 34"/>
+          <p:cNvPr id="40" name="TextBox 39"/>
           <p:cNvSpPr txBox="1"/>
           <p:nvPr/>
         </p:nvSpPr>
         <p:spPr>
           <a:xfrm>
-            <a:off x="594360" y="1783080"/>
-            <a:ext cx="1618488" cy="786384"/>
+            <a:off x="594360" y="1965960"/>
+            <a:ext cx="1664208" cy="740664"/>
           </a:xfrm>
           <a:prstGeom prst="rect">
             <a:avLst/>
@@ -4450,7 +4648,7 @@
                 </a:solidFill>
                 <a:latin typeface="Calibri"/>
               </a:rPr>
-              <a:t>Credit card platform</a:t>
+              <a:t>Credit card systems</a:t>
             </a:r>
           </a:p>
           <a:p>
@@ -4469,25 +4667,25 @@
                 </a:solidFill>
                 <a:latin typeface="Calibri"/>
               </a:rPr>
-              <a:t>Authorization · MCC · spend events</a:t>
-            </a:r>
-          </a:p>
-        </p:txBody>
-      </p:sp>
-      <p:sp>
-        <p:nvSpPr>
-          <p:cNvPr id="36" name="Rounded Rectangle 35"/>
+              <a:t>Spend / auth events</a:t>
+            </a:r>
+          </a:p>
+        </p:txBody>
+      </p:sp>
+      <p:sp>
+        <p:nvSpPr>
+          <p:cNvPr id="41" name="Rounded Rectangle 40"/>
           <p:cNvSpPr/>
           <p:nvPr/>
         </p:nvSpPr>
         <p:spPr>
           <a:xfrm>
-            <a:off x="502920" y="2743200"/>
-            <a:ext cx="1783080" cy="914400"/>
+            <a:off x="502920" y="2880360"/>
+            <a:ext cx="1828800" cy="868680"/>
           </a:xfrm>
           <a:prstGeom prst="roundRect">
             <a:avLst>
-              <a:gd name="adj" fmla="val 4000"/>
+              <a:gd name="adj" fmla="val 3000"/>
             </a:avLst>
           </a:prstGeom>
           <a:solidFill>
@@ -4523,14 +4721,14 @@
       </p:sp>
       <p:sp>
         <p:nvSpPr>
-          <p:cNvPr id="37" name="TextBox 36"/>
+          <p:cNvPr id="42" name="TextBox 41"/>
           <p:cNvSpPr txBox="1"/>
           <p:nvPr/>
         </p:nvSpPr>
         <p:spPr>
           <a:xfrm>
-            <a:off x="594360" y="2834640"/>
-            <a:ext cx="1618488" cy="786384"/>
+            <a:off x="594360" y="2971800"/>
+            <a:ext cx="1664208" cy="740664"/>
           </a:xfrm>
           <a:prstGeom prst="rect">
             <a:avLst/>
@@ -4558,7 +4756,7 @@
                 </a:solidFill>
                 <a:latin typeface="Calibri"/>
               </a:rPr>
-              <a:t>Loan platform</a:t>
+              <a:t>Loan systems</a:t>
             </a:r>
           </a:p>
           <a:p>
@@ -4577,25 +4775,25 @@
                 </a:solidFill>
                 <a:latin typeface="Calibri"/>
               </a:rPr>
-              <a:t>Drawdown · DD · load events</a:t>
-            </a:r>
-          </a:p>
-        </p:txBody>
-      </p:sp>
-      <p:sp>
-        <p:nvSpPr>
-          <p:cNvPr id="38" name="Rounded Rectangle 37"/>
+              <a:t>Drawdown / DD events</a:t>
+            </a:r>
+          </a:p>
+        </p:txBody>
+      </p:sp>
+      <p:sp>
+        <p:nvSpPr>
+          <p:cNvPr id="43" name="Rounded Rectangle 42"/>
           <p:cNvSpPr/>
           <p:nvPr/>
         </p:nvSpPr>
         <p:spPr>
           <a:xfrm>
-            <a:off x="502920" y="3794760"/>
-            <a:ext cx="1783080" cy="914400"/>
+            <a:off x="502920" y="3886200"/>
+            <a:ext cx="1828800" cy="868680"/>
           </a:xfrm>
           <a:prstGeom prst="roundRect">
             <a:avLst>
-              <a:gd name="adj" fmla="val 4000"/>
+              <a:gd name="adj" fmla="val 3000"/>
             </a:avLst>
           </a:prstGeom>
           <a:solidFill>
@@ -4631,14 +4829,14 @@
       </p:sp>
       <p:sp>
         <p:nvSpPr>
-          <p:cNvPr id="39" name="TextBox 38"/>
+          <p:cNvPr id="44" name="TextBox 43"/>
           <p:cNvSpPr txBox="1"/>
           <p:nvPr/>
         </p:nvSpPr>
         <p:spPr>
           <a:xfrm>
-            <a:off x="594360" y="3886200"/>
-            <a:ext cx="1618488" cy="786384"/>
+            <a:off x="594360" y="3977640"/>
+            <a:ext cx="1664208" cy="740664"/>
           </a:xfrm>
           <a:prstGeom prst="rect">
             <a:avLst/>
@@ -4666,7 +4864,7 @@
                 </a:solidFill>
                 <a:latin typeface="Calibri"/>
               </a:rPr>
-              <a:t>Channel apps</a:t>
+              <a:t>Digital channels</a:t>
             </a:r>
           </a:p>
           <a:p>
@@ -4685,21 +4883,21 @@
                 </a:solidFill>
                 <a:latin typeface="Calibri"/>
               </a:rPr>
-              <a:t>Yes UA · sim · CRM events</a:t>
-            </a:r>
-          </a:p>
-        </p:txBody>
-      </p:sp>
-      <p:sp>
-        <p:nvSpPr>
-          <p:cNvPr id="40" name="TextBox 39"/>
+              <a:t>Yes UA · sim · CRM</a:t>
+            </a:r>
+          </a:p>
+        </p:txBody>
+      </p:sp>
+      <p:sp>
+        <p:nvSpPr>
+          <p:cNvPr id="45" name="TextBox 44"/>
           <p:cNvSpPr txBox="1"/>
           <p:nvPr/>
         </p:nvSpPr>
         <p:spPr>
           <a:xfrm>
-            <a:off x="521208" y="4983480"/>
-            <a:ext cx="1746504" cy="640080"/>
+            <a:off x="502920" y="5074920"/>
+            <a:ext cx="1828800" cy="640080"/>
           </a:xfrm>
           <a:prstGeom prst="rect">
             <a:avLst/>
@@ -4720,46 +4918,22 @@
                 </a:solidFill>
                 <a:latin typeface="Calibri"/>
               </a:rPr>
-              <a:t>Systems of record.
-No ledger / scoring logic.</a:t>
-            </a:r>
-          </a:p>
-        </p:txBody>
-      </p:sp>
-      <p:pic>
-        <p:nvPicPr>
-          <p:cNvPr id="41" name="Picture 40" descr="sdk.png"/>
-          <p:cNvPicPr>
-            <a:picLocks noChangeAspect="1"/>
-          </p:cNvPicPr>
-          <p:nvPr/>
-        </p:nvPicPr>
-        <p:blipFill>
-          <a:blip r:embed="rId5"/>
-          <a:stretch>
-            <a:fillRect/>
-          </a:stretch>
-        </p:blipFill>
-        <p:spPr>
-          <a:xfrm>
-            <a:off x="2715768" y="1261872"/>
-            <a:ext cx="256032" cy="256032"/>
-          </a:xfrm>
-          <a:prstGeom prst="rect">
-            <a:avLst/>
-          </a:prstGeom>
-        </p:spPr>
-      </p:pic>
-      <p:sp>
-        <p:nvSpPr>
-          <p:cNvPr id="42" name="TextBox 41"/>
+              <a:t>Stay as systems of record.
+Emit business events only.</a:t>
+            </a:r>
+          </a:p>
+        </p:txBody>
+      </p:sp>
+      <p:sp>
+        <p:nvSpPr>
+          <p:cNvPr id="46" name="TextBox 45"/>
           <p:cNvSpPr txBox="1"/>
           <p:nvPr/>
         </p:nvSpPr>
         <p:spPr>
           <a:xfrm>
-            <a:off x="3008376" y="1280160"/>
-            <a:ext cx="1463040" cy="219456"/>
+            <a:off x="2697480" y="1828800"/>
+            <a:ext cx="1783080" cy="320040"/>
           </a:xfrm>
           <a:prstGeom prst="rect">
             <a:avLst/>
@@ -4774,31 +4948,32 @@
           <a:p>
             <a:pPr algn="l"/>
             <a:r>
-              <a:rPr sz="1100" b="1">
-                <a:solidFill>
-                  <a:srgbClr val="18181B"/>
+              <a:rPr sz="1000" b="0">
+                <a:solidFill>
+                  <a:srgbClr val="71717A"/>
                 </a:solidFill>
                 <a:latin typeface="Calibri"/>
               </a:rPr>
-              <a:t>ledger-engine-sdk</a:t>
-            </a:r>
-          </a:p>
-        </p:txBody>
-      </p:sp>
-      <p:sp>
-        <p:nvSpPr>
-          <p:cNvPr id="43" name="Rounded Rectangle 42"/>
+              <a:t>Thin, standard connectors
+(REST · bus · batch)</a:t>
+            </a:r>
+          </a:p>
+        </p:txBody>
+      </p:sp>
+      <p:sp>
+        <p:nvSpPr>
+          <p:cNvPr id="47" name="Rounded Rectangle 46"/>
           <p:cNvSpPr/>
           <p:nvPr/>
         </p:nvSpPr>
         <p:spPr>
           <a:xfrm>
-            <a:off x="2697480" y="1737360"/>
-            <a:ext cx="1783080" cy="868680"/>
+            <a:off x="2697480" y="2331720"/>
+            <a:ext cx="1783080" cy="777240"/>
           </a:xfrm>
           <a:prstGeom prst="roundRect">
             <a:avLst>
-              <a:gd name="adj" fmla="val 4000"/>
+              <a:gd name="adj" fmla="val 3000"/>
             </a:avLst>
           </a:prstGeom>
           <a:solidFill>
@@ -4834,22 +5009,22 @@
       </p:sp>
       <p:pic>
         <p:nvPicPr>
-          <p:cNvPr id="44" name="Picture 43" descr="rest.png"/>
+          <p:cNvPr id="48" name="Picture 47" descr="rest.png"/>
           <p:cNvPicPr>
             <a:picLocks noChangeAspect="1"/>
           </p:cNvPicPr>
           <p:nvPr/>
         </p:nvPicPr>
         <p:blipFill>
-          <a:blip r:embed="rId6"/>
+          <a:blip r:embed="rId4"/>
           <a:stretch>
             <a:fillRect/>
           </a:stretch>
         </p:blipFill>
         <p:spPr>
           <a:xfrm>
-            <a:off x="2770632" y="1993392"/>
-            <a:ext cx="292608" cy="292608"/>
+            <a:off x="2770632" y="2560320"/>
+            <a:ext cx="274320" cy="274320"/>
           </a:xfrm>
           <a:prstGeom prst="rect">
             <a:avLst/>
@@ -4858,14 +5033,14 @@
       </p:pic>
       <p:sp>
         <p:nvSpPr>
-          <p:cNvPr id="45" name="TextBox 44"/>
+          <p:cNvPr id="49" name="TextBox 48"/>
           <p:cNvSpPr txBox="1"/>
           <p:nvPr/>
         </p:nvSpPr>
         <p:spPr>
           <a:xfrm>
-            <a:off x="3118104" y="1901952"/>
-            <a:ext cx="1280160" cy="640080"/>
+            <a:off x="3108960" y="2496312"/>
+            <a:ext cx="1280160" cy="548640"/>
           </a:xfrm>
           <a:prstGeom prst="rect">
             <a:avLst/>
@@ -4893,7 +5068,7 @@
                 </a:solidFill>
                 <a:latin typeface="Calibri"/>
               </a:rPr>
-              <a:t>REST</a:t>
+              <a:t>REST API</a:t>
             </a:r>
           </a:p>
           <a:p>
@@ -4912,25 +5087,25 @@
                 </a:solidFill>
                 <a:latin typeface="Calibri"/>
               </a:rPr>
-              <a:t>Synchronous invoke · catalog · dry-run</a:t>
-            </a:r>
-          </a:p>
-        </p:txBody>
-      </p:sp>
-      <p:sp>
-        <p:nvSpPr>
-          <p:cNvPr id="46" name="Rounded Rectangle 45"/>
+              <a:t>Use-case invoke</a:t>
+            </a:r>
+          </a:p>
+        </p:txBody>
+      </p:sp>
+      <p:sp>
+        <p:nvSpPr>
+          <p:cNvPr id="50" name="Rounded Rectangle 49"/>
           <p:cNvSpPr/>
           <p:nvPr/>
         </p:nvSpPr>
         <p:spPr>
           <a:xfrm>
-            <a:off x="2697480" y="2743200"/>
-            <a:ext cx="1783080" cy="868680"/>
+            <a:off x="2697480" y="3200400"/>
+            <a:ext cx="1783080" cy="777240"/>
           </a:xfrm>
           <a:prstGeom prst="roundRect">
             <a:avLst>
-              <a:gd name="adj" fmla="val 4000"/>
+              <a:gd name="adj" fmla="val 3000"/>
             </a:avLst>
           </a:prstGeom>
           <a:solidFill>
@@ -4966,22 +5141,22 @@
       </p:sp>
       <p:pic>
         <p:nvPicPr>
-          <p:cNvPr id="47" name="Picture 46" descr="kafka.png"/>
+          <p:cNvPr id="51" name="Picture 50" descr="kafka.png"/>
           <p:cNvPicPr>
             <a:picLocks noChangeAspect="1"/>
           </p:cNvPicPr>
           <p:nvPr/>
         </p:nvPicPr>
         <p:blipFill>
-          <a:blip r:embed="rId7"/>
+          <a:blip r:embed="rId5"/>
           <a:stretch>
             <a:fillRect/>
           </a:stretch>
         </p:blipFill>
         <p:spPr>
           <a:xfrm>
-            <a:off x="2770632" y="2999232"/>
-            <a:ext cx="292608" cy="292608"/>
+            <a:off x="2770632" y="3429000"/>
+            <a:ext cx="274320" cy="274320"/>
           </a:xfrm>
           <a:prstGeom prst="rect">
             <a:avLst/>
@@ -4990,14 +5165,14 @@
       </p:pic>
       <p:sp>
         <p:nvSpPr>
-          <p:cNvPr id="48" name="TextBox 47"/>
+          <p:cNvPr id="52" name="TextBox 51"/>
           <p:cNvSpPr txBox="1"/>
           <p:nvPr/>
         </p:nvSpPr>
         <p:spPr>
           <a:xfrm>
-            <a:off x="3118104" y="2907792"/>
-            <a:ext cx="1280160" cy="640080"/>
+            <a:off x="3108960" y="3364992"/>
+            <a:ext cx="1280160" cy="548640"/>
           </a:xfrm>
           <a:prstGeom prst="rect">
             <a:avLst/>
@@ -5025,7 +5200,7 @@
                 </a:solidFill>
                 <a:latin typeface="Calibri"/>
               </a:rPr>
-              <a:t>Message bus</a:t>
+              <a:t>Event bus</a:t>
             </a:r>
           </a:p>
           <a:p>
@@ -5044,25 +5219,25 @@
                 </a:solidFill>
                 <a:latin typeface="Calibri"/>
               </a:rPr>
-              <a:t>Async event publish / consume</a:t>
-            </a:r>
-          </a:p>
-        </p:txBody>
-      </p:sp>
-      <p:sp>
-        <p:nvSpPr>
-          <p:cNvPr id="49" name="Rounded Rectangle 48"/>
+              <a:t>Async delivery</a:t>
+            </a:r>
+          </a:p>
+        </p:txBody>
+      </p:sp>
+      <p:sp>
+        <p:nvSpPr>
+          <p:cNvPr id="53" name="Rounded Rectangle 52"/>
           <p:cNvSpPr/>
           <p:nvPr/>
         </p:nvSpPr>
         <p:spPr>
           <a:xfrm>
-            <a:off x="2697480" y="3749040"/>
-            <a:ext cx="1783080" cy="868680"/>
+            <a:off x="2697480" y="4069080"/>
+            <a:ext cx="1783080" cy="777240"/>
           </a:xfrm>
           <a:prstGeom prst="roundRect">
             <a:avLst>
-              <a:gd name="adj" fmla="val 4000"/>
+              <a:gd name="adj" fmla="val 3000"/>
             </a:avLst>
           </a:prstGeom>
           <a:solidFill>
@@ -5098,22 +5273,22 @@
       </p:sp>
       <p:pic>
         <p:nvPicPr>
-          <p:cNvPr id="50" name="Picture 49" descr="file.png"/>
+          <p:cNvPr id="54" name="Picture 53" descr="file.png"/>
           <p:cNvPicPr>
             <a:picLocks noChangeAspect="1"/>
           </p:cNvPicPr>
           <p:nvPr/>
         </p:nvPicPr>
         <p:blipFill>
-          <a:blip r:embed="rId8"/>
+          <a:blip r:embed="rId6"/>
           <a:stretch>
             <a:fillRect/>
           </a:stretch>
         </p:blipFill>
         <p:spPr>
           <a:xfrm>
-            <a:off x="2770632" y="4005072"/>
-            <a:ext cx="292608" cy="292608"/>
+            <a:off x="2770632" y="4297680"/>
+            <a:ext cx="274320" cy="274320"/>
           </a:xfrm>
           <a:prstGeom prst="rect">
             <a:avLst/>
@@ -5122,14 +5297,14 @@
       </p:pic>
       <p:sp>
         <p:nvSpPr>
-          <p:cNvPr id="51" name="TextBox 50"/>
+          <p:cNvPr id="55" name="TextBox 54"/>
           <p:cNvSpPr txBox="1"/>
           <p:nvPr/>
         </p:nvSpPr>
         <p:spPr>
           <a:xfrm>
-            <a:off x="3118104" y="3913632"/>
-            <a:ext cx="1280160" cy="640080"/>
+            <a:off x="3108960" y="4233672"/>
+            <a:ext cx="1280160" cy="548640"/>
           </a:xfrm>
           <a:prstGeom prst="rect">
             <a:avLst/>
@@ -5157,7 +5332,7 @@
                 </a:solidFill>
                 <a:latin typeface="Calibri"/>
               </a:rPr>
-              <a:t>Batch / file</a:t>
+              <a:t>Batch</a:t>
             </a:r>
           </a:p>
           <a:p>
@@ -5176,21 +5351,21 @@
                 </a:solidFill>
                 <a:latin typeface="Calibri"/>
               </a:rPr>
-              <a:t>Bulk ingest path</a:t>
-            </a:r>
-          </a:p>
-        </p:txBody>
-      </p:sp>
-      <p:sp>
-        <p:nvSpPr>
-          <p:cNvPr id="52" name="TextBox 51"/>
+              <a:t>File / bulk path</a:t>
+            </a:r>
+          </a:p>
+        </p:txBody>
+      </p:sp>
+      <p:sp>
+        <p:nvSpPr>
+          <p:cNvPr id="56" name="TextBox 55"/>
           <p:cNvSpPr txBox="1"/>
           <p:nvPr/>
         </p:nvSpPr>
         <p:spPr>
           <a:xfrm>
-            <a:off x="2715768" y="4937760"/>
-            <a:ext cx="1746504" cy="685800"/>
+            <a:off x="2697480" y="5120640"/>
+            <a:ext cx="1783080" cy="594360"/>
           </a:xfrm>
           <a:prstGeom prst="rect">
             <a:avLst/>
@@ -5211,23 +5386,69 @@
                 </a:solidFill>
                 <a:latin typeface="Calibri"/>
               </a:rPr>
-              <a:t>Contract: ownerId + use-case code.
-Idempotent delivery.
-No raw ledger JSON from upstream.</a:t>
-            </a:r>
-          </a:p>
-        </p:txBody>
-      </p:sp>
-      <p:sp>
-        <p:nvSpPr>
-          <p:cNvPr id="53" name="TextBox 52"/>
+              <a:t>Stable contract:
+ownerId + use-case code</a:t>
+            </a:r>
+          </a:p>
+        </p:txBody>
+      </p:sp>
+      <p:sp>
+        <p:nvSpPr>
+          <p:cNvPr id="57" name="Rounded Rectangle 56"/>
+          <p:cNvSpPr/>
+          <p:nvPr/>
+        </p:nvSpPr>
+        <p:spPr>
+          <a:xfrm>
+            <a:off x="4846320" y="1810512"/>
+            <a:ext cx="1371600" cy="237744"/>
+          </a:xfrm>
+          <a:prstGeom prst="roundRect">
+            <a:avLst>
+              <a:gd name="adj" fmla="val 4000"/>
+            </a:avLst>
+          </a:prstGeom>
+          <a:solidFill>
+            <a:srgbClr val="F0FDF4"/>
+          </a:solidFill>
+          <a:ln w="12700">
+            <a:solidFill>
+              <a:srgbClr val="14532D"/>
+            </a:solidFill>
+          </a:ln>
+        </p:spPr>
+        <p:style>
+          <a:lnRef idx="1">
+            <a:schemeClr val="accent1"/>
+          </a:lnRef>
+          <a:fillRef idx="3">
+            <a:schemeClr val="accent1"/>
+          </a:fillRef>
+          <a:effectRef idx="2">
+            <a:schemeClr val="accent1"/>
+          </a:effectRef>
+          <a:fontRef idx="minor">
+            <a:schemeClr val="lt1"/>
+          </a:fontRef>
+        </p:style>
+        <p:txBody>
+          <a:bodyPr rtlCol="0" anchor="ctr"/>
+          <a:lstStyle/>
+          <a:p>
+            <a:pPr algn="ctr"/>
+          </a:p>
+        </p:txBody>
+      </p:sp>
+      <p:sp>
+        <p:nvSpPr>
+          <p:cNvPr id="58" name="TextBox 57"/>
           <p:cNvSpPr txBox="1"/>
           <p:nvPr/>
         </p:nvSpPr>
         <p:spPr>
           <a:xfrm>
-            <a:off x="4910328" y="1261872"/>
-            <a:ext cx="3438144" cy="219456"/>
+            <a:off x="4846320" y="1828800"/>
+            <a:ext cx="1371600" cy="201168"/>
           </a:xfrm>
           <a:prstGeom prst="rect">
             <a:avLst/>
@@ -5240,33 +5461,68 @@
           </a:bodyPr>
           <a:lstStyle/>
           <a:p>
-            <a:pPr algn="l"/>
-            <a:r>
-              <a:rPr sz="1000" b="0">
-                <a:solidFill>
-                  <a:srgbClr val="71717A"/>
+            <a:pPr algn="ctr"/>
+            <a:r>
+              <a:rPr sz="900" b="1">
+                <a:solidFill>
+                  <a:srgbClr val="14532D"/>
                 </a:solidFill>
                 <a:latin typeface="Calibri"/>
               </a:rPr>
-              <a:t>In-cluster service set  ·  maps to UA Reward System</a:t>
-            </a:r>
-          </a:p>
-        </p:txBody>
-      </p:sp>
-      <p:sp>
-        <p:nvSpPr>
-          <p:cNvPr id="54" name="Rounded Rectangle 53"/>
+              <a:t>NEW DOMAIN BUILD</a:t>
+            </a:r>
+          </a:p>
+        </p:txBody>
+      </p:sp>
+      <p:sp>
+        <p:nvSpPr>
+          <p:cNvPr id="59" name="TextBox 58"/>
+          <p:cNvSpPr txBox="1"/>
+          <p:nvPr/>
+        </p:nvSpPr>
+        <p:spPr>
+          <a:xfrm>
+            <a:off x="6309360" y="1828800"/>
+            <a:ext cx="1783080" cy="219456"/>
+          </a:xfrm>
+          <a:prstGeom prst="rect">
+            <a:avLst/>
+          </a:prstGeom>
+          <a:noFill/>
+        </p:spPr>
+        <p:txBody>
+          <a:bodyPr wrap="square" lIns="25400" rIns="25400" tIns="0" bIns="0">
+            <a:spAutoFit/>
+          </a:bodyPr>
+          <a:lstStyle/>
+          <a:p>
+            <a:pPr algn="l"/>
+            <a:r>
+              <a:rPr sz="1100" b="1">
+                <a:solidFill>
+                  <a:srgbClr val="18181B"/>
+                </a:solidFill>
+                <a:latin typeface="Calibri"/>
+              </a:rPr>
+              <a:t>LedgeRX capability  =  Reward System</a:t>
+            </a:r>
+          </a:p>
+        </p:txBody>
+      </p:sp>
+      <p:sp>
+        <p:nvSpPr>
+          <p:cNvPr id="60" name="Rounded Rectangle 59"/>
           <p:cNvSpPr/>
           <p:nvPr/>
         </p:nvSpPr>
         <p:spPr>
           <a:xfrm>
-            <a:off x="4910328" y="1600200"/>
-            <a:ext cx="1668780" cy="777240"/>
+            <a:off x="4846320" y="2176272"/>
+            <a:ext cx="1600200" cy="658368"/>
           </a:xfrm>
           <a:prstGeom prst="roundRect">
             <a:avLst>
-              <a:gd name="adj" fmla="val 4000"/>
+              <a:gd name="adj" fmla="val 3000"/>
             </a:avLst>
           </a:prstGeom>
           <a:solidFill>
@@ -5302,14 +5558,14 @@
       </p:sp>
       <p:sp>
         <p:nvSpPr>
-          <p:cNvPr id="55" name="TextBox 54"/>
+          <p:cNvPr id="61" name="TextBox 60"/>
           <p:cNvSpPr txBox="1"/>
           <p:nvPr/>
         </p:nvSpPr>
         <p:spPr>
           <a:xfrm>
-            <a:off x="5001768" y="1691640"/>
-            <a:ext cx="1504188" cy="649224"/>
+            <a:off x="4937760" y="2267712"/>
+            <a:ext cx="1435608" cy="530352"/>
           </a:xfrm>
           <a:prstGeom prst="rect">
             <a:avLst/>
@@ -5337,7 +5593,7 @@
                 </a:solidFill>
                 <a:latin typeface="Calibri"/>
               </a:rPr>
-              <a:t>Onboarding</a:t>
+              <a:t>Customer onboarding</a:t>
             </a:r>
           </a:p>
           <a:p>
@@ -5356,25 +5612,25 @@
                 </a:solidFill>
                 <a:latin typeface="Calibri"/>
               </a:rPr>
-              <a:t>Wallet / owner / currencies</a:t>
-            </a:r>
-          </a:p>
-        </p:txBody>
-      </p:sp>
-      <p:sp>
-        <p:nvSpPr>
-          <p:cNvPr id="56" name="Rounded Rectangle 55"/>
+              <a:t>Wallet · multi-currency</a:t>
+            </a:r>
+          </a:p>
+        </p:txBody>
+      </p:sp>
+      <p:sp>
+        <p:nvSpPr>
+          <p:cNvPr id="62" name="Rounded Rectangle 61"/>
           <p:cNvSpPr/>
           <p:nvPr/>
         </p:nvSpPr>
         <p:spPr>
           <a:xfrm>
-            <a:off x="6670548" y="1600200"/>
-            <a:ext cx="1668780" cy="777240"/>
+            <a:off x="6537960" y="2176272"/>
+            <a:ext cx="1600200" cy="658368"/>
           </a:xfrm>
           <a:prstGeom prst="roundRect">
             <a:avLst>
-              <a:gd name="adj" fmla="val 4000"/>
+              <a:gd name="adj" fmla="val 3000"/>
             </a:avLst>
           </a:prstGeom>
           <a:solidFill>
@@ -5410,14 +5666,14 @@
       </p:sp>
       <p:sp>
         <p:nvSpPr>
-          <p:cNvPr id="57" name="TextBox 56"/>
+          <p:cNvPr id="63" name="TextBox 62"/>
           <p:cNvSpPr txBox="1"/>
           <p:nvPr/>
         </p:nvSpPr>
         <p:spPr>
           <a:xfrm>
-            <a:off x="6761988" y="1691640"/>
-            <a:ext cx="1504188" cy="649224"/>
+            <a:off x="6629400" y="2267712"/>
+            <a:ext cx="1435608" cy="530352"/>
           </a:xfrm>
           <a:prstGeom prst="rect">
             <a:avLst/>
@@ -5445,7 +5701,7 @@
                 </a:solidFill>
                 <a:latin typeface="Calibri"/>
               </a:rPr>
-              <a:t>Referrer mgmt</a:t>
+              <a:t>Referrer management</a:t>
             </a:r>
           </a:p>
           <a:p>
@@ -5464,25 +5720,25 @@
                 </a:solidFill>
                 <a:latin typeface="Calibri"/>
               </a:rPr>
-              <a:t>Referral rule set</a:t>
-            </a:r>
-          </a:p>
-        </p:txBody>
-      </p:sp>
-      <p:sp>
-        <p:nvSpPr>
-          <p:cNvPr id="58" name="Rounded Rectangle 57"/>
+              <a:t>Referral rules</a:t>
+            </a:r>
+          </a:p>
+        </p:txBody>
+      </p:sp>
+      <p:sp>
+        <p:nvSpPr>
+          <p:cNvPr id="64" name="Rounded Rectangle 63"/>
           <p:cNvSpPr/>
           <p:nvPr/>
         </p:nvSpPr>
         <p:spPr>
           <a:xfrm>
-            <a:off x="4910328" y="2468880"/>
-            <a:ext cx="1668780" cy="777240"/>
+            <a:off x="4846320" y="2907792"/>
+            <a:ext cx="1600200" cy="658368"/>
           </a:xfrm>
           <a:prstGeom prst="roundRect">
             <a:avLst>
-              <a:gd name="adj" fmla="val 4000"/>
+              <a:gd name="adj" fmla="val 3000"/>
             </a:avLst>
           </a:prstGeom>
           <a:solidFill>
@@ -5518,14 +5774,14 @@
       </p:sp>
       <p:sp>
         <p:nvSpPr>
-          <p:cNvPr id="59" name="TextBox 58"/>
+          <p:cNvPr id="65" name="TextBox 64"/>
           <p:cNvSpPr txBox="1"/>
           <p:nvPr/>
         </p:nvSpPr>
         <p:spPr>
           <a:xfrm>
-            <a:off x="5001768" y="2560320"/>
-            <a:ext cx="1504188" cy="649224"/>
+            <a:off x="4937760" y="2999232"/>
+            <a:ext cx="1435608" cy="530352"/>
           </a:xfrm>
           <a:prstGeom prst="rect">
             <a:avLst/>
@@ -5579,18 +5835,18 @@
       </p:sp>
       <p:sp>
         <p:nvSpPr>
-          <p:cNvPr id="60" name="Rounded Rectangle 59"/>
+          <p:cNvPr id="66" name="Rounded Rectangle 65"/>
           <p:cNvSpPr/>
           <p:nvPr/>
         </p:nvSpPr>
         <p:spPr>
           <a:xfrm>
-            <a:off x="6670548" y="2468880"/>
-            <a:ext cx="1668780" cy="777240"/>
+            <a:off x="6537960" y="2907792"/>
+            <a:ext cx="1600200" cy="658368"/>
           </a:xfrm>
           <a:prstGeom prst="roundRect">
             <a:avLst>
-              <a:gd name="adj" fmla="val 4000"/>
+              <a:gd name="adj" fmla="val 3000"/>
             </a:avLst>
           </a:prstGeom>
           <a:solidFill>
@@ -5626,14 +5882,14 @@
       </p:sp>
       <p:sp>
         <p:nvSpPr>
-          <p:cNvPr id="61" name="TextBox 60"/>
+          <p:cNvPr id="67" name="TextBox 66"/>
           <p:cNvSpPr txBox="1"/>
           <p:nvPr/>
         </p:nvSpPr>
         <p:spPr>
           <a:xfrm>
-            <a:off x="6761988" y="2560320"/>
-            <a:ext cx="1504188" cy="649224"/>
+            <a:off x="6629400" y="2999232"/>
+            <a:ext cx="1435608" cy="530352"/>
           </a:xfrm>
           <a:prstGeom prst="rect">
             <a:avLst/>
@@ -5680,25 +5936,25 @@
                 </a:solidFill>
                 <a:latin typeface="Calibri"/>
               </a:rPr>
-              <a:t>Multi-currency balances</a:t>
-            </a:r>
-          </a:p>
-        </p:txBody>
-      </p:sp>
-      <p:sp>
-        <p:nvSpPr>
-          <p:cNvPr id="62" name="Rounded Rectangle 61"/>
+              <a:t>Balances · movements</a:t>
+            </a:r>
+          </a:p>
+        </p:txBody>
+      </p:sp>
+      <p:sp>
+        <p:nvSpPr>
+          <p:cNvPr id="68" name="Rounded Rectangle 67"/>
           <p:cNvSpPr/>
           <p:nvPr/>
         </p:nvSpPr>
         <p:spPr>
           <a:xfrm>
-            <a:off x="4910328" y="3337560"/>
-            <a:ext cx="1668780" cy="777240"/>
+            <a:off x="4846320" y="3639312"/>
+            <a:ext cx="1600200" cy="658368"/>
           </a:xfrm>
           <a:prstGeom prst="roundRect">
             <a:avLst>
-              <a:gd name="adj" fmla="val 4000"/>
+              <a:gd name="adj" fmla="val 3000"/>
             </a:avLst>
           </a:prstGeom>
           <a:solidFill>
@@ -5734,14 +5990,14 @@
       </p:sp>
       <p:sp>
         <p:nvSpPr>
-          <p:cNvPr id="63" name="TextBox 62"/>
+          <p:cNvPr id="69" name="TextBox 68"/>
           <p:cNvSpPr txBox="1"/>
           <p:nvPr/>
         </p:nvSpPr>
         <p:spPr>
           <a:xfrm>
-            <a:off x="5001768" y="3429000"/>
-            <a:ext cx="1504188" cy="649224"/>
+            <a:off x="4937760" y="3730752"/>
+            <a:ext cx="1435608" cy="530352"/>
           </a:xfrm>
           <a:prstGeom prst="rect">
             <a:avLst/>
@@ -5769,7 +6025,7 @@
                 </a:solidFill>
                 <a:latin typeface="Calibri"/>
               </a:rPr>
-              <a:t>Account rules</a:t>
+              <a:t>Account rules (COA)</a:t>
             </a:r>
           </a:p>
           <a:p>
@@ -5788,25 +6044,25 @@
                 </a:solidFill>
                 <a:latin typeface="Calibri"/>
               </a:rPr>
-              <a:t>COA profiles</a:t>
-            </a:r>
-          </a:p>
-        </p:txBody>
-      </p:sp>
-      <p:sp>
-        <p:nvSpPr>
-          <p:cNvPr id="64" name="Rounded Rectangle 63"/>
+              <a:t>Finance profiles</a:t>
+            </a:r>
+          </a:p>
+        </p:txBody>
+      </p:sp>
+      <p:sp>
+        <p:nvSpPr>
+          <p:cNvPr id="70" name="Rounded Rectangle 69"/>
           <p:cNvSpPr/>
           <p:nvPr/>
         </p:nvSpPr>
         <p:spPr>
           <a:xfrm>
-            <a:off x="6670548" y="3337560"/>
-            <a:ext cx="1668780" cy="777240"/>
+            <a:off x="6537960" y="3639312"/>
+            <a:ext cx="1600200" cy="658368"/>
           </a:xfrm>
           <a:prstGeom prst="roundRect">
             <a:avLst>
-              <a:gd name="adj" fmla="val 4000"/>
+              <a:gd name="adj" fmla="val 3000"/>
             </a:avLst>
           </a:prstGeom>
           <a:solidFill>
@@ -5842,14 +6098,14 @@
       </p:sp>
       <p:sp>
         <p:nvSpPr>
-          <p:cNvPr id="65" name="TextBox 64"/>
+          <p:cNvPr id="71" name="TextBox 70"/>
           <p:cNvSpPr txBox="1"/>
           <p:nvPr/>
         </p:nvSpPr>
         <p:spPr>
           <a:xfrm>
-            <a:off x="6761988" y="3429000"/>
-            <a:ext cx="1504188" cy="649224"/>
+            <a:off x="6629400" y="3730752"/>
+            <a:ext cx="1435608" cy="530352"/>
           </a:xfrm>
           <a:prstGeom prst="rect">
             <a:avLst/>
@@ -5877,7 +6133,7 @@
                 </a:solidFill>
                 <a:latin typeface="Calibri"/>
               </a:rPr>
-              <a:t>Calculation</a:t>
+              <a:t>Points calculation</a:t>
             </a:r>
           </a:p>
           <a:p>
@@ -5896,25 +6152,25 @@
                 </a:solidFill>
                 <a:latin typeface="Calibri"/>
               </a:rPr>
-              <a:t>Formulas · FIXED / RATE</a:t>
-            </a:r>
-          </a:p>
-        </p:txBody>
-      </p:sp>
-      <p:sp>
-        <p:nvSpPr>
-          <p:cNvPr id="66" name="Rounded Rectangle 65"/>
+              <a:t>Formula engine</a:t>
+            </a:r>
+          </a:p>
+        </p:txBody>
+      </p:sp>
+      <p:sp>
+        <p:nvSpPr>
+          <p:cNvPr id="72" name="Rounded Rectangle 71"/>
           <p:cNvSpPr/>
           <p:nvPr/>
         </p:nvSpPr>
         <p:spPr>
           <a:xfrm>
-            <a:off x="4910328" y="4343400"/>
-            <a:ext cx="3438144" cy="411480"/>
+            <a:off x="4846320" y="4434840"/>
+            <a:ext cx="3337560" cy="384048"/>
           </a:xfrm>
           <a:prstGeom prst="roundRect">
             <a:avLst>
-              <a:gd name="adj" fmla="val 4000"/>
+              <a:gd name="adj" fmla="val 3000"/>
             </a:avLst>
           </a:prstGeom>
           <a:solidFill>
@@ -5950,14 +6206,14 @@
       </p:sp>
       <p:sp>
         <p:nvSpPr>
-          <p:cNvPr id="67" name="TextBox 66"/>
+          <p:cNvPr id="73" name="TextBox 72"/>
           <p:cNvSpPr txBox="1"/>
           <p:nvPr/>
         </p:nvSpPr>
         <p:spPr>
           <a:xfrm>
-            <a:off x="4965192" y="4434840"/>
-            <a:ext cx="3337560" cy="256032"/>
+            <a:off x="4901184" y="4498848"/>
+            <a:ext cx="3246120" cy="256032"/>
           </a:xfrm>
           <a:prstGeom prst="rect">
             <a:avLst/>
@@ -5978,21 +6234,21 @@
                 </a:solidFill>
                 <a:latin typeface="Calibri"/>
               </a:rPr>
-              <a:t>Path: Event → admit → calculate → post → books → outbound event</a:t>
-            </a:r>
-          </a:p>
-        </p:txBody>
-      </p:sp>
-      <p:sp>
-        <p:nvSpPr>
-          <p:cNvPr id="68" name="TextBox 67"/>
+              <a:t>Runtime: event → admit → calculate → post → books → outbound</a:t>
+            </a:r>
+          </a:p>
+        </p:txBody>
+      </p:sp>
+      <p:sp>
+        <p:nvSpPr>
+          <p:cNvPr id="74" name="TextBox 73"/>
           <p:cNvSpPr txBox="1"/>
           <p:nvPr/>
         </p:nvSpPr>
         <p:spPr>
           <a:xfrm>
-            <a:off x="4910328" y="4937760"/>
-            <a:ext cx="3438144" cy="685800"/>
+            <a:off x="4846320" y="4983480"/>
+            <a:ext cx="3337560" cy="731520"/>
           </a:xfrm>
           <a:prstGeom prst="rect">
             <a:avLst/>
@@ -6013,22 +6269,22 @@
                 </a:solidFill>
                 <a:latin typeface="Calibri"/>
               </a:rPr>
-              <a:t>Configuration (ops): digestion rules, COA, use-case catalog.
-Upstream does not embed formulas.</a:t>
-            </a:r>
-          </a:p>
-        </p:txBody>
-      </p:sp>
-      <p:sp>
-        <p:nvSpPr>
-          <p:cNvPr id="69" name="TextBox 68"/>
+              <a:t>Ops-owned configuration (rules, COA, catalog).
+Channel teams call use-cases — they do not re-implement ledger math.</a:t>
+            </a:r>
+          </a:p>
+        </p:txBody>
+      </p:sp>
+      <p:sp>
+        <p:nvSpPr>
+          <p:cNvPr id="75" name="TextBox 74"/>
           <p:cNvSpPr txBox="1"/>
           <p:nvPr/>
         </p:nvSpPr>
         <p:spPr>
           <a:xfrm>
-            <a:off x="8732520" y="1280160"/>
-            <a:ext cx="1234440" cy="457200"/>
+            <a:off x="8549640" y="1828800"/>
+            <a:ext cx="1234440" cy="411480"/>
           </a:xfrm>
           <a:prstGeom prst="rect">
             <a:avLst/>
@@ -6049,26 +6305,26 @@
                 </a:solidFill>
                 <a:latin typeface="Calibri"/>
               </a:rPr>
-              <a:t>Optional modules
-beside core</a:t>
-            </a:r>
-          </a:p>
-        </p:txBody>
-      </p:sp>
-      <p:sp>
-        <p:nvSpPr>
-          <p:cNvPr id="70" name="Rounded Rectangle 69"/>
+              <a:t>Planned extensions
+without forking core</a:t>
+            </a:r>
+          </a:p>
+        </p:txBody>
+      </p:sp>
+      <p:sp>
+        <p:nvSpPr>
+          <p:cNvPr id="76" name="Rounded Rectangle 75"/>
           <p:cNvSpPr/>
           <p:nvPr/>
         </p:nvSpPr>
         <p:spPr>
           <a:xfrm>
-            <a:off x="8732520" y="1920240"/>
-            <a:ext cx="1234440" cy="822960"/>
+            <a:off x="8549640" y="2423160"/>
+            <a:ext cx="1234440" cy="777240"/>
           </a:xfrm>
           <a:prstGeom prst="roundRect">
             <a:avLst>
-              <a:gd name="adj" fmla="val 4000"/>
+              <a:gd name="adj" fmla="val 3000"/>
             </a:avLst>
           </a:prstGeom>
           <a:solidFill>
@@ -6104,14 +6360,14 @@
       </p:sp>
       <p:sp>
         <p:nvSpPr>
-          <p:cNvPr id="71" name="TextBox 70"/>
+          <p:cNvPr id="77" name="TextBox 76"/>
           <p:cNvSpPr txBox="1"/>
           <p:nvPr/>
         </p:nvSpPr>
         <p:spPr>
           <a:xfrm>
-            <a:off x="8823960" y="2011680"/>
-            <a:ext cx="1069848" cy="694944"/>
+            <a:off x="8641080" y="2514600"/>
+            <a:ext cx="1069848" cy="649224"/>
           </a:xfrm>
           <a:prstGeom prst="rect">
             <a:avLst/>
@@ -6158,25 +6414,25 @@
                 </a:solidFill>
                 <a:latin typeface="Calibri"/>
               </a:rPr>
-              <a:t>Extension slot</a:t>
-            </a:r>
-          </a:p>
-        </p:txBody>
-      </p:sp>
-      <p:sp>
-        <p:nvSpPr>
-          <p:cNvPr id="72" name="Rounded Rectangle 71"/>
+              <a:t>Roadmap slot</a:t>
+            </a:r>
+          </a:p>
+        </p:txBody>
+      </p:sp>
+      <p:sp>
+        <p:nvSpPr>
+          <p:cNvPr id="78" name="Rounded Rectangle 77"/>
           <p:cNvSpPr/>
           <p:nvPr/>
         </p:nvSpPr>
         <p:spPr>
           <a:xfrm>
-            <a:off x="8732520" y="2880360"/>
-            <a:ext cx="1234440" cy="822960"/>
+            <a:off x="8549640" y="3337560"/>
+            <a:ext cx="1234440" cy="777240"/>
           </a:xfrm>
           <a:prstGeom prst="roundRect">
             <a:avLst>
-              <a:gd name="adj" fmla="val 4000"/>
+              <a:gd name="adj" fmla="val 3000"/>
             </a:avLst>
           </a:prstGeom>
           <a:solidFill>
@@ -6212,14 +6468,14 @@
       </p:sp>
       <p:sp>
         <p:nvSpPr>
-          <p:cNvPr id="73" name="TextBox 72"/>
+          <p:cNvPr id="79" name="TextBox 78"/>
           <p:cNvSpPr txBox="1"/>
           <p:nvPr/>
         </p:nvSpPr>
         <p:spPr>
           <a:xfrm>
-            <a:off x="8823960" y="2971800"/>
-            <a:ext cx="1069848" cy="694944"/>
+            <a:off x="8641080" y="3429000"/>
+            <a:ext cx="1069848" cy="649224"/>
           </a:xfrm>
           <a:prstGeom prst="rect">
             <a:avLst/>
@@ -6266,25 +6522,25 @@
                 </a:solidFill>
                 <a:latin typeface="Calibri"/>
               </a:rPr>
-              <a:t>Extension slot</a:t>
-            </a:r>
-          </a:p>
-        </p:txBody>
-      </p:sp>
-      <p:sp>
-        <p:nvSpPr>
-          <p:cNvPr id="74" name="Rounded Rectangle 73"/>
+              <a:t>Roadmap slot</a:t>
+            </a:r>
+          </a:p>
+        </p:txBody>
+      </p:sp>
+      <p:sp>
+        <p:nvSpPr>
+          <p:cNvPr id="80" name="Rounded Rectangle 79"/>
           <p:cNvSpPr/>
           <p:nvPr/>
         </p:nvSpPr>
         <p:spPr>
           <a:xfrm>
-            <a:off x="8732520" y="3840480"/>
-            <a:ext cx="1234440" cy="822960"/>
+            <a:off x="8549640" y="4251960"/>
+            <a:ext cx="1234440" cy="777240"/>
           </a:xfrm>
           <a:prstGeom prst="roundRect">
             <a:avLst>
-              <a:gd name="adj" fmla="val 4000"/>
+              <a:gd name="adj" fmla="val 3000"/>
             </a:avLst>
           </a:prstGeom>
           <a:solidFill>
@@ -6320,14 +6576,14 @@
       </p:sp>
       <p:sp>
         <p:nvSpPr>
-          <p:cNvPr id="75" name="TextBox 74"/>
+          <p:cNvPr id="81" name="TextBox 80"/>
           <p:cNvSpPr txBox="1"/>
           <p:nvPr/>
         </p:nvSpPr>
         <p:spPr>
           <a:xfrm>
-            <a:off x="8823960" y="3931920"/>
-            <a:ext cx="1069848" cy="694944"/>
+            <a:off x="8641080" y="4343400"/>
+            <a:ext cx="1069848" cy="649224"/>
           </a:xfrm>
           <a:prstGeom prst="rect">
             <a:avLst/>
@@ -6355,7 +6611,7 @@
                 </a:solidFill>
                 <a:latin typeface="Calibri"/>
               </a:rPr>
-              <a:t>TBD</a:t>
+              <a:t>Future modules</a:t>
             </a:r>
           </a:p>
           <a:p>
@@ -6374,21 +6630,21 @@
                 </a:solidFill>
                 <a:latin typeface="Calibri"/>
               </a:rPr>
-              <a:t>Extension slot</a:t>
-            </a:r>
-          </a:p>
-        </p:txBody>
-      </p:sp>
-      <p:sp>
-        <p:nvSpPr>
-          <p:cNvPr id="76" name="TextBox 75"/>
+              <a:t>Roadmap slot</a:t>
+            </a:r>
+          </a:p>
+        </p:txBody>
+      </p:sp>
+      <p:sp>
+        <p:nvSpPr>
+          <p:cNvPr id="82" name="TextBox 81"/>
           <p:cNvSpPr txBox="1"/>
           <p:nvPr/>
         </p:nvSpPr>
         <p:spPr>
           <a:xfrm>
-            <a:off x="10332720" y="1261872"/>
-            <a:ext cx="1371600" cy="365760"/>
+            <a:off x="10149840" y="1810512"/>
+            <a:ext cx="1554480" cy="365760"/>
           </a:xfrm>
           <a:prstGeom prst="rect">
             <a:avLst/>
@@ -6409,26 +6665,26 @@
                 </a:solidFill>
                 <a:latin typeface="Calibri"/>
               </a:rPr>
-              <a:t>Via UAF landing
-hub (slide 2)</a:t>
-            </a:r>
-          </a:p>
-        </p:txBody>
-      </p:sp>
-      <p:sp>
-        <p:nvSpPr>
-          <p:cNvPr id="77" name="Rounded Rectangle 76"/>
+              <a:t>Behind UAF hub
+(see slide 2)</a:t>
+            </a:r>
+          </a:p>
+        </p:txBody>
+      </p:sp>
+      <p:sp>
+        <p:nvSpPr>
+          <p:cNvPr id="83" name="Rounded Rectangle 82"/>
           <p:cNvSpPr/>
           <p:nvPr/>
         </p:nvSpPr>
         <p:spPr>
           <a:xfrm>
-            <a:off x="10332720" y="1828800"/>
-            <a:ext cx="1371600" cy="731520"/>
+            <a:off x="10149840" y="2331720"/>
+            <a:ext cx="1554480" cy="685800"/>
           </a:xfrm>
           <a:prstGeom prst="roundRect">
             <a:avLst>
-              <a:gd name="adj" fmla="val 4000"/>
+              <a:gd name="adj" fmla="val 3000"/>
             </a:avLst>
           </a:prstGeom>
           <a:solidFill>
@@ -6464,14 +6720,14 @@
       </p:sp>
       <p:sp>
         <p:nvSpPr>
-          <p:cNvPr id="78" name="TextBox 77"/>
+          <p:cNvPr id="84" name="TextBox 83"/>
           <p:cNvSpPr txBox="1"/>
           <p:nvPr/>
         </p:nvSpPr>
         <p:spPr>
           <a:xfrm>
-            <a:off x="10424160" y="1938528"/>
-            <a:ext cx="1207008" cy="585216"/>
+            <a:off x="10241280" y="2459736"/>
+            <a:ext cx="1389888" cy="521208"/>
           </a:xfrm>
           <a:prstGeom prst="rect">
             <a:avLst/>
@@ -6499,18 +6755,18 @@
       </p:sp>
       <p:sp>
         <p:nvSpPr>
-          <p:cNvPr id="79" name="Rounded Rectangle 78"/>
+          <p:cNvPr id="85" name="Rounded Rectangle 84"/>
           <p:cNvSpPr/>
           <p:nvPr/>
         </p:nvSpPr>
         <p:spPr>
           <a:xfrm>
-            <a:off x="10332720" y="2651760"/>
-            <a:ext cx="1371600" cy="731520"/>
+            <a:off x="10149840" y="3108960"/>
+            <a:ext cx="1554480" cy="685800"/>
           </a:xfrm>
           <a:prstGeom prst="roundRect">
             <a:avLst>
-              <a:gd name="adj" fmla="val 4000"/>
+              <a:gd name="adj" fmla="val 3000"/>
             </a:avLst>
           </a:prstGeom>
           <a:solidFill>
@@ -6546,14 +6802,14 @@
       </p:sp>
       <p:sp>
         <p:nvSpPr>
-          <p:cNvPr id="80" name="TextBox 79"/>
+          <p:cNvPr id="86" name="TextBox 85"/>
           <p:cNvSpPr txBox="1"/>
           <p:nvPr/>
         </p:nvSpPr>
         <p:spPr>
           <a:xfrm>
-            <a:off x="10424160" y="2761488"/>
-            <a:ext cx="1207008" cy="585216"/>
+            <a:off x="10241280" y="3236976"/>
+            <a:ext cx="1389888" cy="521208"/>
           </a:xfrm>
           <a:prstGeom prst="rect">
             <a:avLst/>
@@ -6581,18 +6837,18 @@
       </p:sp>
       <p:sp>
         <p:nvSpPr>
-          <p:cNvPr id="81" name="Rounded Rectangle 80"/>
+          <p:cNvPr id="87" name="Rounded Rectangle 86"/>
           <p:cNvSpPr/>
           <p:nvPr/>
         </p:nvSpPr>
         <p:spPr>
           <a:xfrm>
-            <a:off x="10332720" y="3474720"/>
-            <a:ext cx="1371600" cy="731520"/>
+            <a:off x="10149840" y="3886200"/>
+            <a:ext cx="1554480" cy="685800"/>
           </a:xfrm>
           <a:prstGeom prst="roundRect">
             <a:avLst>
-              <a:gd name="adj" fmla="val 4000"/>
+              <a:gd name="adj" fmla="val 3000"/>
             </a:avLst>
           </a:prstGeom>
           <a:solidFill>
@@ -6628,14 +6884,14 @@
       </p:sp>
       <p:sp>
         <p:nvSpPr>
-          <p:cNvPr id="82" name="TextBox 81"/>
+          <p:cNvPr id="88" name="TextBox 87"/>
           <p:cNvSpPr txBox="1"/>
           <p:nvPr/>
         </p:nvSpPr>
         <p:spPr>
           <a:xfrm>
-            <a:off x="10424160" y="3584448"/>
-            <a:ext cx="1207008" cy="585216"/>
+            <a:off x="10241280" y="4014216"/>
+            <a:ext cx="1389888" cy="521208"/>
           </a:xfrm>
           <a:prstGeom prst="rect">
             <a:avLst/>
@@ -6663,18 +6919,18 @@
       </p:sp>
       <p:sp>
         <p:nvSpPr>
-          <p:cNvPr id="83" name="Rounded Rectangle 82"/>
+          <p:cNvPr id="89" name="Rounded Rectangle 88"/>
           <p:cNvSpPr/>
           <p:nvPr/>
         </p:nvSpPr>
         <p:spPr>
           <a:xfrm>
-            <a:off x="10332720" y="4297680"/>
-            <a:ext cx="1371600" cy="731520"/>
+            <a:off x="10149840" y="4663440"/>
+            <a:ext cx="1554480" cy="685800"/>
           </a:xfrm>
           <a:prstGeom prst="roundRect">
             <a:avLst>
-              <a:gd name="adj" fmla="val 4000"/>
+              <a:gd name="adj" fmla="val 3000"/>
             </a:avLst>
           </a:prstGeom>
           <a:solidFill>
@@ -6710,14 +6966,14 @@
       </p:sp>
       <p:sp>
         <p:nvSpPr>
-          <p:cNvPr id="84" name="TextBox 83"/>
+          <p:cNvPr id="90" name="TextBox 89"/>
           <p:cNvSpPr txBox="1"/>
           <p:nvPr/>
         </p:nvSpPr>
         <p:spPr>
           <a:xfrm>
-            <a:off x="10424160" y="4407408"/>
-            <a:ext cx="1207008" cy="585216"/>
+            <a:off x="10241280" y="4791456"/>
+            <a:ext cx="1389888" cy="521208"/>
           </a:xfrm>
           <a:prstGeom prst="rect">
             <a:avLst/>
@@ -6745,14 +7001,14 @@
       </p:sp>
       <p:sp>
         <p:nvSpPr>
-          <p:cNvPr id="85" name="Rectangle 84"/>
+          <p:cNvPr id="91" name="Rectangle 90"/>
           <p:cNvSpPr/>
           <p:nvPr/>
         </p:nvSpPr>
         <p:spPr>
           <a:xfrm>
-            <a:off x="0" y="6537960"/>
-            <a:ext cx="12191695" cy="320040"/>
+            <a:off x="0" y="6172200"/>
+            <a:ext cx="12191695" cy="685800"/>
           </a:xfrm>
           <a:prstGeom prst="rect">
             <a:avLst/>
@@ -6788,14 +7044,14 @@
       </p:sp>
       <p:sp>
         <p:nvSpPr>
-          <p:cNvPr id="86" name="TextBox 85"/>
+          <p:cNvPr id="92" name="TextBox 91"/>
           <p:cNvSpPr txBox="1"/>
           <p:nvPr/>
         </p:nvSpPr>
         <p:spPr>
           <a:xfrm>
-            <a:off x="411480" y="6583680"/>
-            <a:ext cx="9144000" cy="219456"/>
+            <a:off x="411480" y="6309360"/>
+            <a:ext cx="10972800" cy="411480"/>
           </a:xfrm>
           <a:prstGeom prst="rect">
             <a:avLst/>
@@ -6810,48 +7066,14 @@
           <a:p>
             <a:pPr algn="l"/>
             <a:r>
-              <a:rPr sz="1000" b="0">
+              <a:rPr sz="1100" b="0">
                 <a:solidFill>
                   <a:srgbClr val="3F3F46"/>
                 </a:solidFill>
                 <a:latin typeface="Calibri"/>
               </a:rPr>
-              <a:t>Boundary: LedgeRX owns reward ledger &amp; calculation  ·  UAF owns channel systems and landing orchestration</a:t>
-            </a:r>
-          </a:p>
-        </p:txBody>
-      </p:sp>
-      <p:sp>
-        <p:nvSpPr>
-          <p:cNvPr id="87" name="TextBox 86"/>
-          <p:cNvSpPr txBox="1"/>
-          <p:nvPr/>
-        </p:nvSpPr>
-        <p:spPr>
-          <a:xfrm>
-            <a:off x="10515600" y="6583680"/>
-            <a:ext cx="1280160" cy="219456"/>
-          </a:xfrm>
-          <a:prstGeom prst="rect">
-            <a:avLst/>
-          </a:prstGeom>
-          <a:noFill/>
-        </p:spPr>
-        <p:txBody>
-          <a:bodyPr wrap="square" lIns="25400" rIns="25400" tIns="0" bIns="0">
-            <a:spAutoFit/>
-          </a:bodyPr>
-          <a:lstStyle/>
-          <a:p>
-            <a:pPr algn="r"/>
-            <a:r>
-              <a:rPr sz="1000" b="0">
-                <a:solidFill>
-                  <a:srgbClr val="71717A"/>
-                </a:solidFill>
-                <a:latin typeface="Calibri"/>
-              </a:rPr>
-              <a:t>Confidential</a:t>
+              <a:t>CTO narrative: We are standing up a modern rewards domain with clean boundaries — channels stay thin, ledger capability is centralized, fulfillment remains ours.
+This is UAF platform architecture — not a vendor black box dropped in the middle.</a:t>
             </a:r>
           </a:p>
         </p:txBody>
@@ -6960,79 +7182,9 @@
           </a:p>
         </p:txBody>
       </p:sp>
-      <p:sp>
-        <p:nvSpPr>
-          <p:cNvPr id="4" name="TextBox 3"/>
-          <p:cNvSpPr txBox="1"/>
-          <p:nvPr/>
-        </p:nvSpPr>
-        <p:spPr>
-          <a:xfrm>
-            <a:off x="411480" y="164592"/>
-            <a:ext cx="8229600" cy="256032"/>
-          </a:xfrm>
-          <a:prstGeom prst="rect">
-            <a:avLst/>
-          </a:prstGeom>
-          <a:noFill/>
-        </p:spPr>
-        <p:txBody>
-          <a:bodyPr wrap="square" lIns="25400" rIns="25400" tIns="0" bIns="0">
-            <a:spAutoFit/>
-          </a:bodyPr>
-          <a:lstStyle/>
-          <a:p>
-            <a:pPr algn="l"/>
-            <a:r>
-              <a:rPr sz="2000" b="1">
-                <a:solidFill>
-                  <a:srgbClr val="18181B"/>
-                </a:solidFill>
-                <a:latin typeface="Calibri"/>
-              </a:rPr>
-              <a:t>Landing interface — single UAF integration point</a:t>
-            </a:r>
-          </a:p>
-        </p:txBody>
-      </p:sp>
-      <p:sp>
-        <p:nvSpPr>
-          <p:cNvPr id="5" name="TextBox 4"/>
-          <p:cNvSpPr txBox="1"/>
-          <p:nvPr/>
-        </p:nvSpPr>
-        <p:spPr>
-          <a:xfrm>
-            <a:off x="411480" y="438912"/>
-            <a:ext cx="8229600" cy="201168"/>
-          </a:xfrm>
-          <a:prstGeom prst="rect">
-            <a:avLst/>
-          </a:prstGeom>
-          <a:noFill/>
-        </p:spPr>
-        <p:txBody>
-          <a:bodyPr wrap="square" lIns="25400" rIns="25400" tIns="0" bIns="0">
-            <a:spAutoFit/>
-          </a:bodyPr>
-          <a:lstStyle/>
-          <a:p>
-            <a:pPr algn="l"/>
-            <a:r>
-              <a:rPr sz="1100" b="0">
-                <a:solidFill>
-                  <a:srgbClr val="71717A"/>
-                </a:solidFill>
-                <a:latin typeface="Calibri"/>
-              </a:rPr>
-              <a:t>LedgeRX emits domain events  ·  one UAF-owned hub consumes them  ·  internal systems are not direct peers</a:t>
-            </a:r>
-          </a:p>
-        </p:txBody>
-      </p:sp>
       <p:pic>
         <p:nvPicPr>
-          <p:cNvPr id="6" name="Picture 5" descr="uaf_badge_48.png"/>
+          <p:cNvPr id="4" name="Picture 3" descr="uaf_badge_48.png"/>
           <p:cNvPicPr>
             <a:picLocks noChangeAspect="1"/>
           </p:cNvPicPr>
@@ -7046,48 +7198,24 @@
         </p:blipFill>
         <p:spPr>
           <a:xfrm>
-            <a:off x="9144000" y="182880"/>
-            <a:ext cx="1097280" cy="347472"/>
+            <a:off x="411480" y="146304"/>
+            <a:ext cx="1143000" cy="365760"/>
           </a:xfrm>
           <a:prstGeom prst="rect">
             <a:avLst/>
           </a:prstGeom>
         </p:spPr>
       </p:pic>
-      <p:pic>
-        <p:nvPicPr>
-          <p:cNvPr id="7" name="Picture 6" descr="sim_mark_40.png"/>
-          <p:cNvPicPr>
-            <a:picLocks noChangeAspect="1"/>
-          </p:cNvPicPr>
-          <p:nvPr/>
-        </p:nvPicPr>
-        <p:blipFill>
-          <a:blip r:embed="rId3"/>
-          <a:stretch>
-            <a:fillRect/>
-          </a:stretch>
-        </p:blipFill>
-        <p:spPr>
-          <a:xfrm>
-            <a:off x="10378440" y="201168"/>
-            <a:ext cx="329184" cy="329184"/>
-          </a:xfrm>
-          <a:prstGeom prst="rect">
-            <a:avLst/>
-          </a:prstGeom>
-        </p:spPr>
-      </p:pic>
-      <p:sp>
-        <p:nvSpPr>
-          <p:cNvPr id="8" name="TextBox 7"/>
+      <p:sp>
+        <p:nvSpPr>
+          <p:cNvPr id="5" name="TextBox 4"/>
           <p:cNvSpPr txBox="1"/>
           <p:nvPr/>
         </p:nvSpPr>
         <p:spPr>
           <a:xfrm>
-            <a:off x="10789920" y="256032"/>
-            <a:ext cx="822960" cy="219456"/>
+            <a:off x="1691640" y="146304"/>
+            <a:ext cx="8229600" cy="256032"/>
           </a:xfrm>
           <a:prstGeom prst="rect">
             <a:avLst/>
@@ -7102,6 +7230,76 @@
           <a:p>
             <a:pPr algn="l"/>
             <a:r>
+              <a:rPr sz="1800" b="1">
+                <a:solidFill>
+                  <a:srgbClr val="18181B"/>
+                </a:solidFill>
+                <a:latin typeface="Calibri"/>
+              </a:rPr>
+              <a:t>How UAF owns the landing path</a:t>
+            </a:r>
+          </a:p>
+        </p:txBody>
+      </p:sp>
+      <p:sp>
+        <p:nvSpPr>
+          <p:cNvPr id="6" name="TextBox 5"/>
+          <p:cNvSpPr txBox="1"/>
+          <p:nvPr/>
+        </p:nvSpPr>
+        <p:spPr>
+          <a:xfrm>
+            <a:off x="1691640" y="420624"/>
+            <a:ext cx="8229600" cy="201168"/>
+          </a:xfrm>
+          <a:prstGeom prst="rect">
+            <a:avLst/>
+          </a:prstGeom>
+          <a:noFill/>
+        </p:spPr>
+        <p:txBody>
+          <a:bodyPr wrap="square" lIns="25400" rIns="25400" tIns="0" bIns="0">
+            <a:spAutoFit/>
+          </a:bodyPr>
+          <a:lstStyle/>
+          <a:p>
+            <a:pPr algn="l"/>
+            <a:r>
+              <a:rPr sz="1100" b="0">
+                <a:solidFill>
+                  <a:srgbClr val="71717A"/>
+                </a:solidFill>
+                <a:latin typeface="Calibri"/>
+              </a:rPr>
+              <a:t>One UAF-built hub is the only counterpart to the reward ledger  ·  everything else is our internal topology</a:t>
+            </a:r>
+          </a:p>
+        </p:txBody>
+      </p:sp>
+      <p:sp>
+        <p:nvSpPr>
+          <p:cNvPr id="7" name="TextBox 6"/>
+          <p:cNvSpPr txBox="1"/>
+          <p:nvPr/>
+        </p:nvSpPr>
+        <p:spPr>
+          <a:xfrm>
+            <a:off x="10881360" y="237744"/>
+            <a:ext cx="822960" cy="219456"/>
+          </a:xfrm>
+          <a:prstGeom prst="rect">
+            <a:avLst/>
+          </a:prstGeom>
+          <a:noFill/>
+        </p:spPr>
+        <p:txBody>
+          <a:bodyPr wrap="square" lIns="25400" rIns="25400" tIns="0" bIns="0">
+            <a:spAutoFit/>
+          </a:bodyPr>
+          <a:lstStyle/>
+          <a:p>
+            <a:pPr algn="l"/>
+            <a:r>
               <a:rPr sz="1100" b="0">
                 <a:solidFill>
                   <a:srgbClr val="71717A"/>
@@ -7115,14 +7313,14 @@
       </p:sp>
       <p:sp>
         <p:nvSpPr>
-          <p:cNvPr id="9" name="Rounded Rectangle 8"/>
+          <p:cNvPr id="8" name="Rounded Rectangle 7"/>
           <p:cNvSpPr/>
           <p:nvPr/>
         </p:nvSpPr>
         <p:spPr>
           <a:xfrm>
-            <a:off x="411480" y="822960"/>
-            <a:ext cx="11365992" cy="1051560"/>
+            <a:off x="411480" y="777240"/>
+            <a:ext cx="11365992" cy="960120"/>
           </a:xfrm>
           <a:prstGeom prst="roundRect">
             <a:avLst>
@@ -7132,7 +7330,7 @@
           <a:solidFill>
             <a:srgbClr val="E8EEF4"/>
           </a:solidFill>
-          <a:ln w="19050">
+          <a:ln w="17145">
             <a:solidFill>
               <a:srgbClr val="1E3A5F"/>
             </a:solidFill>
@@ -7162,14 +7360,61 @@
       </p:sp>
       <p:sp>
         <p:nvSpPr>
+          <p:cNvPr id="9" name="Rounded Rectangle 8"/>
+          <p:cNvSpPr/>
+          <p:nvPr/>
+        </p:nvSpPr>
+        <p:spPr>
+          <a:xfrm>
+            <a:off x="548640" y="886968"/>
+            <a:ext cx="2103120" cy="237744"/>
+          </a:xfrm>
+          <a:prstGeom prst="roundRect">
+            <a:avLst>
+              <a:gd name="adj" fmla="val 4000"/>
+            </a:avLst>
+          </a:prstGeom>
+          <a:solidFill>
+            <a:srgbClr val="F0FDF4"/>
+          </a:solidFill>
+          <a:ln w="12700">
+            <a:solidFill>
+              <a:srgbClr val="14532D"/>
+            </a:solidFill>
+          </a:ln>
+        </p:spPr>
+        <p:style>
+          <a:lnRef idx="1">
+            <a:schemeClr val="accent1"/>
+          </a:lnRef>
+          <a:fillRef idx="3">
+            <a:schemeClr val="accent1"/>
+          </a:fillRef>
+          <a:effectRef idx="2">
+            <a:schemeClr val="accent1"/>
+          </a:effectRef>
+          <a:fontRef idx="minor">
+            <a:schemeClr val="lt1"/>
+          </a:fontRef>
+        </p:style>
+        <p:txBody>
+          <a:bodyPr rtlCol="0" anchor="ctr"/>
+          <a:lstStyle/>
+          <a:p>
+            <a:pPr algn="ctr"/>
+          </a:p>
+        </p:txBody>
+      </p:sp>
+      <p:sp>
+        <p:nvSpPr>
           <p:cNvPr id="10" name="TextBox 9"/>
           <p:cNvSpPr txBox="1"/>
           <p:nvPr/>
         </p:nvSpPr>
         <p:spPr>
           <a:xfrm>
-            <a:off x="548640" y="932688"/>
-            <a:ext cx="2011680" cy="219456"/>
+            <a:off x="548640" y="905256"/>
+            <a:ext cx="2103120" cy="201168"/>
           </a:xfrm>
           <a:prstGeom prst="rect">
             <a:avLst/>
@@ -7182,15 +7427,15 @@
           </a:bodyPr>
           <a:lstStyle/>
           <a:p>
-            <a:pPr algn="l"/>
-            <a:r>
-              <a:rPr sz="1000" b="1">
-                <a:solidFill>
-                  <a:srgbClr val="1E3A5F"/>
+            <a:pPr algn="ctr"/>
+            <a:r>
+              <a:rPr sz="900" b="1">
+                <a:solidFill>
+                  <a:srgbClr val="14532D"/>
                 </a:solidFill>
                 <a:latin typeface="Calibri"/>
               </a:rPr>
-              <a:t>LEDGERX (provider)</a:t>
+              <a:t>CAPABILITY WE STAND UP</a:t>
             </a:r>
           </a:p>
         </p:txBody>
@@ -7203,8 +7448,8 @@
         </p:nvSpPr>
         <p:spPr>
           <a:xfrm>
-            <a:off x="548640" y="1188720"/>
-            <a:ext cx="10972800" cy="256032"/>
+            <a:off x="2834640" y="886968"/>
+            <a:ext cx="8686800" cy="256032"/>
           </a:xfrm>
           <a:prstGeom prst="rect">
             <a:avLst/>
@@ -7225,45 +7470,21 @@
                 </a:solidFill>
                 <a:latin typeface="Calibri"/>
               </a:rPr>
-              <a:t>Reward System  ·  wallets, posting, calculation, books</a:t>
-            </a:r>
-          </a:p>
-        </p:txBody>
-      </p:sp>
-      <p:pic>
-        <p:nvPicPr>
-          <p:cNvPr id="12" name="Picture 11" descr="kafka.png"/>
-          <p:cNvPicPr>
-            <a:picLocks noChangeAspect="1"/>
-          </p:cNvPicPr>
-          <p:nvPr/>
-        </p:nvPicPr>
-        <p:blipFill>
-          <a:blip r:embed="rId4"/>
-          <a:stretch>
-            <a:fillRect/>
-          </a:stretch>
-        </p:blipFill>
-        <p:spPr>
-          <a:xfrm>
-            <a:off x="548640" y="1508760"/>
-            <a:ext cx="219456" cy="219456"/>
-          </a:xfrm>
-          <a:prstGeom prst="rect">
-            <a:avLst/>
-          </a:prstGeom>
-        </p:spPr>
-      </p:pic>
-      <p:sp>
-        <p:nvSpPr>
-          <p:cNvPr id="13" name="TextBox 12"/>
+              <a:t>Reward ledger capability (LedgeRX)  =  UA Reward System</a:t>
+            </a:r>
+          </a:p>
+        </p:txBody>
+      </p:sp>
+      <p:sp>
+        <p:nvSpPr>
+          <p:cNvPr id="12" name="TextBox 11"/>
           <p:cNvSpPr txBox="1"/>
           <p:nvPr/>
         </p:nvSpPr>
         <p:spPr>
           <a:xfrm>
-            <a:off x="868680" y="1508760"/>
-            <a:ext cx="10515600" cy="219456"/>
+            <a:off x="548640" y="1252728"/>
+            <a:ext cx="10972800" cy="365760"/>
           </a:xfrm>
           <a:prstGeom prst="rect">
             <a:avLst/>
@@ -7284,21 +7505,22 @@
                 </a:solidFill>
                 <a:latin typeface="Calibri"/>
               </a:rPr>
-              <a:t>Outbound: balance.updated  ·  redemption request  ·  other ledger outcomes   |   transport: Kafka topic / HTTP callback</a:t>
-            </a:r>
-          </a:p>
-        </p:txBody>
-      </p:sp>
-      <p:sp>
-        <p:nvSpPr>
-          <p:cNvPr id="14" name="Down Arrow 13"/>
+              <a:t>Produces domain outcomes only: balance updates · redemption requests · ledger facts.
+Does not own coupon inventory, partner settlement, or customer notification content.</a:t>
+            </a:r>
+          </a:p>
+        </p:txBody>
+      </p:sp>
+      <p:sp>
+        <p:nvSpPr>
+          <p:cNvPr id="13" name="Down Arrow 12"/>
           <p:cNvSpPr/>
           <p:nvPr/>
         </p:nvSpPr>
         <p:spPr>
           <a:xfrm>
-            <a:off x="5943600" y="1965960"/>
-            <a:ext cx="128016" cy="128016"/>
+            <a:off x="5943600" y="1828800"/>
+            <a:ext cx="118872" cy="118872"/>
           </a:xfrm>
           <a:prstGeom prst="downArrow">
             <a:avLst/>
@@ -7334,14 +7556,14 @@
       </p:sp>
       <p:sp>
         <p:nvSpPr>
-          <p:cNvPr id="15" name="TextBox 14"/>
+          <p:cNvPr id="14" name="TextBox 13"/>
           <p:cNvSpPr txBox="1"/>
           <p:nvPr/>
         </p:nvSpPr>
         <p:spPr>
           <a:xfrm>
-            <a:off x="6172200" y="1965960"/>
-            <a:ext cx="2286000" cy="182880"/>
+            <a:off x="6172200" y="1828800"/>
+            <a:ext cx="2743200" cy="182880"/>
           </a:xfrm>
           <a:prstGeom prst="rect">
             <a:avLst/>
@@ -7362,20 +7584,20 @@
                 </a:solidFill>
                 <a:latin typeface="Calibri"/>
               </a:rPr>
-              <a:t>single interface</a:t>
-            </a:r>
-          </a:p>
-        </p:txBody>
-      </p:sp>
-      <p:sp>
-        <p:nvSpPr>
-          <p:cNvPr id="16" name="Rounded Rectangle 15"/>
+              <a:t>contracted interface</a:t>
+            </a:r>
+          </a:p>
+        </p:txBody>
+      </p:sp>
+      <p:sp>
+        <p:nvSpPr>
+          <p:cNvPr id="15" name="Rounded Rectangle 14"/>
           <p:cNvSpPr/>
           <p:nvPr/>
         </p:nvSpPr>
         <p:spPr>
           <a:xfrm>
-            <a:off x="411480" y="2194560"/>
+            <a:off x="411480" y="2084831"/>
             <a:ext cx="11365992" cy="1417320"/>
           </a:xfrm>
           <a:prstGeom prst="roundRect">
@@ -7416,14 +7638,61 @@
       </p:sp>
       <p:sp>
         <p:nvSpPr>
+          <p:cNvPr id="16" name="Rounded Rectangle 15"/>
+          <p:cNvSpPr/>
+          <p:nvPr/>
+        </p:nvSpPr>
+        <p:spPr>
+          <a:xfrm>
+            <a:off x="548640" y="2176271"/>
+            <a:ext cx="2377440" cy="237744"/>
+          </a:xfrm>
+          <a:prstGeom prst="roundRect">
+            <a:avLst>
+              <a:gd name="adj" fmla="val 3000"/>
+            </a:avLst>
+          </a:prstGeom>
+          <a:solidFill>
+            <a:srgbClr val="1E3A5F"/>
+          </a:solidFill>
+          <a:ln w="12700">
+            <a:solidFill>
+              <a:srgbClr val="D4D4D8"/>
+            </a:solidFill>
+          </a:ln>
+        </p:spPr>
+        <p:style>
+          <a:lnRef idx="1">
+            <a:schemeClr val="accent1"/>
+          </a:lnRef>
+          <a:fillRef idx="3">
+            <a:schemeClr val="accent1"/>
+          </a:fillRef>
+          <a:effectRef idx="2">
+            <a:schemeClr val="accent1"/>
+          </a:effectRef>
+          <a:fontRef idx="minor">
+            <a:schemeClr val="lt1"/>
+          </a:fontRef>
+        </p:style>
+        <p:txBody>
+          <a:bodyPr rtlCol="0" anchor="ctr"/>
+          <a:lstStyle/>
+          <a:p>
+            <a:pPr algn="ctr"/>
+          </a:p>
+        </p:txBody>
+      </p:sp>
+      <p:sp>
+        <p:nvSpPr>
           <p:cNvPr id="17" name="TextBox 16"/>
           <p:cNvSpPr txBox="1"/>
           <p:nvPr/>
         </p:nvSpPr>
         <p:spPr>
           <a:xfrm>
-            <a:off x="548640" y="2286000"/>
-            <a:ext cx="3657600" cy="219456"/>
+            <a:off x="548640" y="2194559"/>
+            <a:ext cx="2377440" cy="201168"/>
           </a:xfrm>
           <a:prstGeom prst="rect">
             <a:avLst/>
@@ -7436,15 +7705,15 @@
           </a:bodyPr>
           <a:lstStyle/>
           <a:p>
-            <a:pPr algn="l"/>
-            <a:r>
-              <a:rPr sz="1000" b="1">
-                <a:solidFill>
-                  <a:srgbClr val="1E3A5F"/>
+            <a:pPr algn="ctr"/>
+            <a:r>
+              <a:rPr sz="900" b="1">
+                <a:solidFill>
+                  <a:srgbClr val="FFFFFF"/>
                 </a:solidFill>
                 <a:latin typeface="Calibri"/>
               </a:rPr>
-              <a:t>UAF LANDING HUB  ·  sole consumer</a:t>
+              <a:t>UAF BUILDS &amp; OWNS THIS</a:t>
             </a:r>
           </a:p>
         </p:txBody>
@@ -7465,7 +7734,7 @@
         </p:blipFill>
         <p:spPr>
           <a:xfrm>
-            <a:off x="4297680" y="2249424"/>
+            <a:off x="3063240" y="2157983"/>
             <a:ext cx="1005840" cy="310896"/>
           </a:xfrm>
           <a:prstGeom prst="rect">
@@ -7481,8 +7750,8 @@
         </p:nvSpPr>
         <p:spPr>
           <a:xfrm>
-            <a:off x="548640" y="2578608"/>
-            <a:ext cx="10972800" cy="237744"/>
+            <a:off x="4206240" y="2194559"/>
+            <a:ext cx="6858000" cy="256032"/>
           </a:xfrm>
           <a:prstGeom prst="rect">
             <a:avLst/>
@@ -7497,31 +7766,66 @@
           <a:p>
             <a:pPr algn="l"/>
             <a:r>
-              <a:rPr sz="1300" b="1">
+              <a:rPr sz="1400" b="1">
                 <a:solidFill>
                   <a:srgbClr val="18181B"/>
                 </a:solidFill>
                 <a:latin typeface="Calibri"/>
               </a:rPr>
-              <a:t>Unified landing layer (UAF-owned) — collect results, apply UAF business rules, route internally</a:t>
-            </a:r>
-          </a:p>
-        </p:txBody>
-      </p:sp>
-      <p:sp>
-        <p:nvSpPr>
-          <p:cNvPr id="20" name="Rounded Rectangle 19"/>
+              <a:t>Unified Landing Hub  —  our orchestration layer</a:t>
+            </a:r>
+          </a:p>
+        </p:txBody>
+      </p:sp>
+      <p:sp>
+        <p:nvSpPr>
+          <p:cNvPr id="20" name="TextBox 19"/>
+          <p:cNvSpPr txBox="1"/>
+          <p:nvPr/>
+        </p:nvSpPr>
+        <p:spPr>
+          <a:xfrm>
+            <a:off x="548640" y="2523743"/>
+            <a:ext cx="10972800" cy="219456"/>
+          </a:xfrm>
+          <a:prstGeom prst="rect">
+            <a:avLst/>
+          </a:prstGeom>
+          <a:noFill/>
+        </p:spPr>
+        <p:txBody>
+          <a:bodyPr wrap="square" lIns="25400" rIns="25400" tIns="0" bIns="0">
+            <a:spAutoFit/>
+          </a:bodyPr>
+          <a:lstStyle/>
+          <a:p>
+            <a:pPr algn="l"/>
+            <a:r>
+              <a:rPr sz="1100" b="0">
+                <a:solidFill>
+                  <a:srgbClr val="3F3F46"/>
+                </a:solidFill>
+                <a:latin typeface="Calibri"/>
+              </a:rPr>
+              <a:t>Single integration surface to the reward ledger. UAF policy, routing, and business decisions live here.</a:t>
+            </a:r>
+          </a:p>
+        </p:txBody>
+      </p:sp>
+      <p:sp>
+        <p:nvSpPr>
+          <p:cNvPr id="21" name="Rounded Rectangle 20"/>
           <p:cNvSpPr/>
           <p:nvPr/>
         </p:nvSpPr>
         <p:spPr>
           <a:xfrm>
-            <a:off x="594360" y="2926080"/>
-            <a:ext cx="3566160" cy="548640"/>
+            <a:off x="594360" y="2862071"/>
+            <a:ext cx="3566160" cy="502920"/>
           </a:xfrm>
           <a:prstGeom prst="roundRect">
             <a:avLst>
-              <a:gd name="adj" fmla="val 4000"/>
+              <a:gd name="adj" fmla="val 3000"/>
             </a:avLst>
           </a:prstGeom>
           <a:solidFill>
@@ -7557,14 +7861,14 @@
       </p:sp>
       <p:sp>
         <p:nvSpPr>
-          <p:cNvPr id="21" name="TextBox 20"/>
+          <p:cNvPr id="22" name="TextBox 21"/>
           <p:cNvSpPr txBox="1"/>
           <p:nvPr/>
         </p:nvSpPr>
         <p:spPr>
           <a:xfrm>
-            <a:off x="704088" y="2999232"/>
-            <a:ext cx="365760" cy="219456"/>
+            <a:off x="704088" y="2926079"/>
+            <a:ext cx="320040" cy="201168"/>
           </a:xfrm>
           <a:prstGeom prst="rect">
             <a:avLst/>
@@ -7579,27 +7883,27 @@
           <a:p>
             <a:pPr algn="l"/>
             <a:r>
-              <a:rPr sz="1100" b="1">
+              <a:rPr sz="1200" b="1">
                 <a:solidFill>
                   <a:srgbClr val="1E3A5F"/>
                 </a:solidFill>
                 <a:latin typeface="Calibri"/>
               </a:rPr>
-              <a:t>01</a:t>
-            </a:r>
-          </a:p>
-        </p:txBody>
-      </p:sp>
-      <p:sp>
-        <p:nvSpPr>
-          <p:cNvPr id="22" name="TextBox 21"/>
+              <a:t>1</a:t>
+            </a:r>
+          </a:p>
+        </p:txBody>
+      </p:sp>
+      <p:sp>
+        <p:nvSpPr>
+          <p:cNvPr id="23" name="TextBox 22"/>
           <p:cNvSpPr txBox="1"/>
           <p:nvPr/>
         </p:nvSpPr>
         <p:spPr>
           <a:xfrm>
-            <a:off x="1051560" y="2999232"/>
-            <a:ext cx="2971800" cy="201168"/>
+            <a:off x="1005840" y="2926079"/>
+            <a:ext cx="3017520" cy="182880"/>
           </a:xfrm>
           <a:prstGeom prst="rect">
             <a:avLst/>
@@ -7620,21 +7924,21 @@
                 </a:solidFill>
                 <a:latin typeface="Calibri"/>
               </a:rPr>
-              <a:t>Ingest</a:t>
-            </a:r>
-          </a:p>
-        </p:txBody>
-      </p:sp>
-      <p:sp>
-        <p:nvSpPr>
-          <p:cNvPr id="23" name="TextBox 22"/>
+              <a:t>Collect</a:t>
+            </a:r>
+          </a:p>
+        </p:txBody>
+      </p:sp>
+      <p:sp>
+        <p:nvSpPr>
+          <p:cNvPr id="24" name="TextBox 23"/>
           <p:cNvSpPr txBox="1"/>
           <p:nvPr/>
         </p:nvSpPr>
         <p:spPr>
           <a:xfrm>
-            <a:off x="1051560" y="3218688"/>
-            <a:ext cx="2971800" cy="201168"/>
+            <a:off x="1005840" y="3127246"/>
+            <a:ext cx="3017520" cy="182880"/>
           </a:xfrm>
           <a:prstGeom prst="rect">
             <a:avLst/>
@@ -7655,25 +7959,25 @@
                 </a:solidFill>
                 <a:latin typeface="Calibri"/>
               </a:rPr>
-              <a:t>Subscribe to LedgeRX events / APIs</a:t>
-            </a:r>
-          </a:p>
-        </p:txBody>
-      </p:sp>
-      <p:sp>
-        <p:nvSpPr>
-          <p:cNvPr id="24" name="Rounded Rectangle 23"/>
+              <a:t>Consume ledger outcomes (bus / API)</a:t>
+            </a:r>
+          </a:p>
+        </p:txBody>
+      </p:sp>
+      <p:sp>
+        <p:nvSpPr>
+          <p:cNvPr id="25" name="Rounded Rectangle 24"/>
           <p:cNvSpPr/>
           <p:nvPr/>
         </p:nvSpPr>
         <p:spPr>
           <a:xfrm>
-            <a:off x="4343400" y="2926080"/>
-            <a:ext cx="3566160" cy="548640"/>
+            <a:off x="4343399" y="2862071"/>
+            <a:ext cx="3566160" cy="502920"/>
           </a:xfrm>
           <a:prstGeom prst="roundRect">
             <a:avLst>
-              <a:gd name="adj" fmla="val 4000"/>
+              <a:gd name="adj" fmla="val 3000"/>
             </a:avLst>
           </a:prstGeom>
           <a:solidFill>
@@ -7709,14 +8013,14 @@
       </p:sp>
       <p:sp>
         <p:nvSpPr>
-          <p:cNvPr id="25" name="TextBox 24"/>
+          <p:cNvPr id="26" name="TextBox 25"/>
           <p:cNvSpPr txBox="1"/>
           <p:nvPr/>
         </p:nvSpPr>
         <p:spPr>
           <a:xfrm>
-            <a:off x="4453128" y="2999232"/>
-            <a:ext cx="365760" cy="219456"/>
+            <a:off x="4453127" y="2926079"/>
+            <a:ext cx="320040" cy="201168"/>
           </a:xfrm>
           <a:prstGeom prst="rect">
             <a:avLst/>
@@ -7731,27 +8035,27 @@
           <a:p>
             <a:pPr algn="l"/>
             <a:r>
-              <a:rPr sz="1100" b="1">
+              <a:rPr sz="1200" b="1">
                 <a:solidFill>
                   <a:srgbClr val="1E3A5F"/>
                 </a:solidFill>
                 <a:latin typeface="Calibri"/>
               </a:rPr>
-              <a:t>02</a:t>
-            </a:r>
-          </a:p>
-        </p:txBody>
-      </p:sp>
-      <p:sp>
-        <p:nvSpPr>
-          <p:cNvPr id="26" name="TextBox 25"/>
+              <a:t>2</a:t>
+            </a:r>
+          </a:p>
+        </p:txBody>
+      </p:sp>
+      <p:sp>
+        <p:nvSpPr>
+          <p:cNvPr id="27" name="TextBox 26"/>
           <p:cNvSpPr txBox="1"/>
           <p:nvPr/>
         </p:nvSpPr>
         <p:spPr>
           <a:xfrm>
-            <a:off x="4800600" y="2999232"/>
-            <a:ext cx="2971800" cy="201168"/>
+            <a:off x="4754879" y="2926079"/>
+            <a:ext cx="3017520" cy="182880"/>
           </a:xfrm>
           <a:prstGeom prst="rect">
             <a:avLst/>
@@ -7772,21 +8076,21 @@
                 </a:solidFill>
                 <a:latin typeface="Calibri"/>
               </a:rPr>
-              <a:t>Orchestrate</a:t>
-            </a:r>
-          </a:p>
-        </p:txBody>
-      </p:sp>
-      <p:sp>
-        <p:nvSpPr>
-          <p:cNvPr id="27" name="TextBox 26"/>
+              <a:t>Decide</a:t>
+            </a:r>
+          </a:p>
+        </p:txBody>
+      </p:sp>
+      <p:sp>
+        <p:nvSpPr>
+          <p:cNvPr id="28" name="TextBox 27"/>
           <p:cNvSpPr txBox="1"/>
           <p:nvPr/>
         </p:nvSpPr>
         <p:spPr>
           <a:xfrm>
-            <a:off x="4800600" y="3218688"/>
-            <a:ext cx="2971800" cy="201168"/>
+            <a:off x="4754879" y="3127246"/>
+            <a:ext cx="3017520" cy="182880"/>
           </a:xfrm>
           <a:prstGeom prst="rect">
             <a:avLst/>
@@ -7807,25 +8111,25 @@
                 </a:solidFill>
                 <a:latin typeface="Calibri"/>
               </a:rPr>
-              <a:t>UAF policy, eligibility, routing</a:t>
-            </a:r>
-          </a:p>
-        </p:txBody>
-      </p:sp>
-      <p:sp>
-        <p:nvSpPr>
-          <p:cNvPr id="28" name="Rounded Rectangle 27"/>
+              <a:t>Apply UAF rules · eligibility · journey</a:t>
+            </a:r>
+          </a:p>
+        </p:txBody>
+      </p:sp>
+      <p:sp>
+        <p:nvSpPr>
+          <p:cNvPr id="29" name="Rounded Rectangle 28"/>
           <p:cNvSpPr/>
           <p:nvPr/>
         </p:nvSpPr>
         <p:spPr>
           <a:xfrm>
-            <a:off x="8092440" y="2926080"/>
-            <a:ext cx="3566160" cy="548640"/>
+            <a:off x="8092438" y="2862071"/>
+            <a:ext cx="3566160" cy="502920"/>
           </a:xfrm>
           <a:prstGeom prst="roundRect">
             <a:avLst>
-              <a:gd name="adj" fmla="val 4000"/>
+              <a:gd name="adj" fmla="val 3000"/>
             </a:avLst>
           </a:prstGeom>
           <a:solidFill>
@@ -7861,14 +8165,14 @@
       </p:sp>
       <p:sp>
         <p:nvSpPr>
-          <p:cNvPr id="29" name="TextBox 28"/>
+          <p:cNvPr id="30" name="TextBox 29"/>
           <p:cNvSpPr txBox="1"/>
           <p:nvPr/>
         </p:nvSpPr>
         <p:spPr>
           <a:xfrm>
-            <a:off x="8202168" y="2999232"/>
-            <a:ext cx="365760" cy="219456"/>
+            <a:off x="8202166" y="2926079"/>
+            <a:ext cx="320040" cy="201168"/>
           </a:xfrm>
           <a:prstGeom prst="rect">
             <a:avLst/>
@@ -7883,27 +8187,27 @@
           <a:p>
             <a:pPr algn="l"/>
             <a:r>
-              <a:rPr sz="1100" b="1">
+              <a:rPr sz="1200" b="1">
                 <a:solidFill>
                   <a:srgbClr val="1E3A5F"/>
                 </a:solidFill>
                 <a:latin typeface="Calibri"/>
               </a:rPr>
-              <a:t>03</a:t>
-            </a:r>
-          </a:p>
-        </p:txBody>
-      </p:sp>
-      <p:sp>
-        <p:nvSpPr>
-          <p:cNvPr id="30" name="TextBox 29"/>
+              <a:t>3</a:t>
+            </a:r>
+          </a:p>
+        </p:txBody>
+      </p:sp>
+      <p:sp>
+        <p:nvSpPr>
+          <p:cNvPr id="31" name="TextBox 30"/>
           <p:cNvSpPr txBox="1"/>
           <p:nvPr/>
         </p:nvSpPr>
         <p:spPr>
           <a:xfrm>
-            <a:off x="8549640" y="2999232"/>
-            <a:ext cx="2971800" cy="201168"/>
+            <a:off x="8503918" y="2926079"/>
+            <a:ext cx="3017520" cy="182880"/>
           </a:xfrm>
           <a:prstGeom prst="rect">
             <a:avLst/>
@@ -7931,14 +8235,14 @@
       </p:sp>
       <p:sp>
         <p:nvSpPr>
-          <p:cNvPr id="31" name="TextBox 30"/>
+          <p:cNvPr id="32" name="TextBox 31"/>
           <p:cNvSpPr txBox="1"/>
           <p:nvPr/>
         </p:nvSpPr>
         <p:spPr>
           <a:xfrm>
-            <a:off x="8549640" y="3218688"/>
-            <a:ext cx="2971800" cy="201168"/>
+            <a:off x="8503918" y="3127246"/>
+            <a:ext cx="3017520" cy="182880"/>
           </a:xfrm>
           <a:prstGeom prst="rect">
             <a:avLst/>
@@ -7959,21 +8263,21 @@
                 </a:solidFill>
                 <a:latin typeface="Calibri"/>
               </a:rPr>
-              <a:t>Invoke internal UAF systems</a:t>
-            </a:r>
-          </a:p>
-        </p:txBody>
-      </p:sp>
-      <p:sp>
-        <p:nvSpPr>
-          <p:cNvPr id="32" name="Down Arrow 31"/>
+              <a:t>Drive CBP, gift, notify, CRM</a:t>
+            </a:r>
+          </a:p>
+        </p:txBody>
+      </p:sp>
+      <p:sp>
+        <p:nvSpPr>
+          <p:cNvPr id="33" name="Down Arrow 32"/>
           <p:cNvSpPr/>
           <p:nvPr/>
         </p:nvSpPr>
         <p:spPr>
           <a:xfrm>
-            <a:off x="1737360" y="3730752"/>
-            <a:ext cx="128016" cy="128016"/>
+            <a:off x="1737360" y="3611880"/>
+            <a:ext cx="118872" cy="118872"/>
           </a:xfrm>
           <a:prstGeom prst="downArrow">
             <a:avLst/>
@@ -8009,14 +8313,14 @@
       </p:sp>
       <p:sp>
         <p:nvSpPr>
-          <p:cNvPr id="33" name="Down Arrow 32"/>
+          <p:cNvPr id="34" name="Down Arrow 33"/>
           <p:cNvSpPr/>
           <p:nvPr/>
         </p:nvSpPr>
         <p:spPr>
           <a:xfrm>
-            <a:off x="4434840" y="3730752"/>
-            <a:ext cx="128016" cy="128016"/>
+            <a:off x="4434840" y="3611880"/>
+            <a:ext cx="118872" cy="118872"/>
           </a:xfrm>
           <a:prstGeom prst="downArrow">
             <a:avLst/>
@@ -8052,14 +8356,14 @@
       </p:sp>
       <p:sp>
         <p:nvSpPr>
-          <p:cNvPr id="34" name="Down Arrow 33"/>
+          <p:cNvPr id="35" name="Down Arrow 34"/>
           <p:cNvSpPr/>
           <p:nvPr/>
         </p:nvSpPr>
         <p:spPr>
           <a:xfrm>
-            <a:off x="7132320" y="3730752"/>
-            <a:ext cx="128016" cy="128016"/>
+            <a:off x="7132320" y="3611880"/>
+            <a:ext cx="118872" cy="118872"/>
           </a:xfrm>
           <a:prstGeom prst="downArrow">
             <a:avLst/>
@@ -8095,14 +8399,14 @@
       </p:sp>
       <p:sp>
         <p:nvSpPr>
-          <p:cNvPr id="35" name="Down Arrow 34"/>
+          <p:cNvPr id="36" name="Down Arrow 35"/>
           <p:cNvSpPr/>
           <p:nvPr/>
         </p:nvSpPr>
         <p:spPr>
           <a:xfrm>
-            <a:off x="9829800" y="3730752"/>
-            <a:ext cx="128016" cy="128016"/>
+            <a:off x="9829800" y="3611880"/>
+            <a:ext cx="118872" cy="118872"/>
           </a:xfrm>
           <a:prstGeom prst="downArrow">
             <a:avLst/>
@@ -8138,13 +8442,13 @@
       </p:sp>
       <p:sp>
         <p:nvSpPr>
-          <p:cNvPr id="36" name="TextBox 35"/>
+          <p:cNvPr id="37" name="TextBox 36"/>
           <p:cNvSpPr txBox="1"/>
           <p:nvPr/>
         </p:nvSpPr>
         <p:spPr>
           <a:xfrm>
-            <a:off x="411480" y="3913632"/>
+            <a:off x="411480" y="3794760"/>
             <a:ext cx="10972800" cy="201168"/>
           </a:xfrm>
           <a:prstGeom prst="rect">
@@ -8166,21 +8470,21 @@
                 </a:solidFill>
                 <a:latin typeface="Calibri"/>
               </a:rPr>
-              <a:t>UAF internal systems (not LedgeRX integration surfaces)</a:t>
-            </a:r>
-          </a:p>
-        </p:txBody>
-      </p:sp>
-      <p:sp>
-        <p:nvSpPr>
-          <p:cNvPr id="37" name="Rounded Rectangle 36"/>
+              <a:t>UAF internal topology — not exposed as ledger integration surfaces</a:t>
+            </a:r>
+          </a:p>
+        </p:txBody>
+      </p:sp>
+      <p:sp>
+        <p:nvSpPr>
+          <p:cNvPr id="38" name="Rounded Rectangle 37"/>
           <p:cNvSpPr/>
           <p:nvPr/>
         </p:nvSpPr>
         <p:spPr>
           <a:xfrm>
-            <a:off x="411480" y="4160520"/>
-            <a:ext cx="2697480" cy="1234440"/>
+            <a:off x="411480" y="4069080"/>
+            <a:ext cx="2697480" cy="1143000"/>
           </a:xfrm>
           <a:prstGeom prst="roundRect">
             <a:avLst>
@@ -8190,7 +8494,7 @@
           <a:solidFill>
             <a:srgbClr val="E8EEF4"/>
           </a:solidFill>
-          <a:ln w="19050">
+          <a:ln w="17145">
             <a:solidFill>
               <a:srgbClr val="1E3A5F"/>
             </a:solidFill>
@@ -8220,13 +8524,13 @@
       </p:sp>
       <p:sp>
         <p:nvSpPr>
-          <p:cNvPr id="38" name="TextBox 37"/>
+          <p:cNvPr id="39" name="TextBox 38"/>
           <p:cNvSpPr txBox="1"/>
           <p:nvPr/>
         </p:nvSpPr>
         <p:spPr>
           <a:xfrm>
-            <a:off x="521208" y="4251960"/>
+            <a:off x="521208" y="4160520"/>
             <a:ext cx="2478024" cy="182880"/>
           </a:xfrm>
           <a:prstGeom prst="rect">
@@ -8248,21 +8552,21 @@
                 </a:solidFill>
                 <a:latin typeface="Calibri"/>
               </a:rPr>
-              <a:t>ONE DOWNSTREAM</a:t>
-            </a:r>
-          </a:p>
-        </p:txBody>
-      </p:sp>
-      <p:sp>
-        <p:nvSpPr>
-          <p:cNvPr id="39" name="TextBox 38"/>
+              <a:t>EXAMPLE DOWNSTREAM</a:t>
+            </a:r>
+          </a:p>
+        </p:txBody>
+      </p:sp>
+      <p:sp>
+        <p:nvSpPr>
+          <p:cNvPr id="40" name="TextBox 39"/>
           <p:cNvSpPr txBox="1"/>
           <p:nvPr/>
         </p:nvSpPr>
         <p:spPr>
           <a:xfrm>
-            <a:off x="521208" y="4480560"/>
-            <a:ext cx="2478024" cy="256032"/>
+            <a:off x="521208" y="4361688"/>
+            <a:ext cx="2478024" cy="237744"/>
           </a:xfrm>
           <a:prstGeom prst="rect">
             <a:avLst/>
@@ -8290,14 +8594,14 @@
       </p:sp>
       <p:sp>
         <p:nvSpPr>
-          <p:cNvPr id="40" name="TextBox 39"/>
+          <p:cNvPr id="41" name="TextBox 40"/>
           <p:cNvSpPr txBox="1"/>
           <p:nvPr/>
         </p:nvSpPr>
         <p:spPr>
           <a:xfrm>
-            <a:off x="521208" y="4800600"/>
-            <a:ext cx="2478024" cy="411480"/>
+            <a:off x="521208" y="4654296"/>
+            <a:ext cx="2478024" cy="457200"/>
           </a:xfrm>
           <a:prstGeom prst="rect">
             <a:avLst/>
@@ -8318,21 +8622,22 @@
                 </a:solidFill>
                 <a:latin typeface="Calibri"/>
               </a:rPr>
-              <a:t>Inventory · issue / redeem · usage tracking</a:t>
-            </a:r>
-          </a:p>
-        </p:txBody>
-      </p:sp>
-      <p:sp>
-        <p:nvSpPr>
-          <p:cNvPr id="41" name="TextBox 40"/>
+              <a:t>Our coupon platform
+inventory · issue · redeem · track</a:t>
+            </a:r>
+          </a:p>
+        </p:txBody>
+      </p:sp>
+      <p:sp>
+        <p:nvSpPr>
+          <p:cNvPr id="42" name="TextBox 41"/>
           <p:cNvSpPr txBox="1"/>
           <p:nvPr/>
         </p:nvSpPr>
         <p:spPr>
           <a:xfrm>
-            <a:off x="521208" y="5102352"/>
-            <a:ext cx="2478024" cy="201168"/>
+            <a:off x="521208" y="4937760"/>
+            <a:ext cx="2478024" cy="182880"/>
           </a:xfrm>
           <a:prstGeom prst="rect">
             <a:avLst/>
@@ -8353,21 +8658,21 @@
                 </a:solidFill>
                 <a:latin typeface="Calibri"/>
               </a:rPr>
-              <a:t>UAF-owned</a:t>
-            </a:r>
-          </a:p>
-        </p:txBody>
-      </p:sp>
-      <p:sp>
-        <p:nvSpPr>
-          <p:cNvPr id="42" name="Rounded Rectangle 41"/>
+              <a:t>UAF-controlled</a:t>
+            </a:r>
+          </a:p>
+        </p:txBody>
+      </p:sp>
+      <p:sp>
+        <p:nvSpPr>
+          <p:cNvPr id="43" name="Rounded Rectangle 42"/>
           <p:cNvSpPr/>
           <p:nvPr/>
         </p:nvSpPr>
         <p:spPr>
           <a:xfrm>
-            <a:off x="3273552" y="4160520"/>
-            <a:ext cx="2697480" cy="1234440"/>
+            <a:off x="3273552" y="4069080"/>
+            <a:ext cx="2697480" cy="1143000"/>
           </a:xfrm>
           <a:prstGeom prst="roundRect">
             <a:avLst>
@@ -8407,14 +8712,14 @@
       </p:sp>
       <p:sp>
         <p:nvSpPr>
-          <p:cNvPr id="43" name="TextBox 42"/>
+          <p:cNvPr id="44" name="TextBox 43"/>
           <p:cNvSpPr txBox="1"/>
           <p:nvPr/>
         </p:nvSpPr>
         <p:spPr>
           <a:xfrm>
-            <a:off x="3383280" y="4297680"/>
-            <a:ext cx="2478024" cy="256032"/>
+            <a:off x="3383280" y="4197096"/>
+            <a:ext cx="2478024" cy="237744"/>
           </a:xfrm>
           <a:prstGeom prst="rect">
             <a:avLst/>
@@ -8435,21 +8740,21 @@
                 </a:solidFill>
                 <a:latin typeface="Calibri"/>
               </a:rPr>
-              <a:t>Gift service</a:t>
-            </a:r>
-          </a:p>
-        </p:txBody>
-      </p:sp>
-      <p:sp>
-        <p:nvSpPr>
-          <p:cNvPr id="44" name="TextBox 43"/>
+              <a:t>Gift systems</a:t>
+            </a:r>
+          </a:p>
+        </p:txBody>
+      </p:sp>
+      <p:sp>
+        <p:nvSpPr>
+          <p:cNvPr id="45" name="TextBox 44"/>
           <p:cNvSpPr txBox="1"/>
           <p:nvPr/>
         </p:nvSpPr>
         <p:spPr>
           <a:xfrm>
-            <a:off x="3383280" y="4617720"/>
-            <a:ext cx="2478024" cy="411480"/>
+            <a:off x="3383280" y="4489704"/>
+            <a:ext cx="2478024" cy="457200"/>
           </a:xfrm>
           <a:prstGeom prst="rect">
             <a:avLst/>
@@ -8470,21 +8775,22 @@
                 </a:solidFill>
                 <a:latin typeface="Calibri"/>
               </a:rPr>
-              <a:t>Fulfillment after routing decision</a:t>
-            </a:r>
-          </a:p>
-        </p:txBody>
-      </p:sp>
-      <p:sp>
-        <p:nvSpPr>
-          <p:cNvPr id="45" name="TextBox 44"/>
+              <a:t>Fulfillment we already run
+triggered by hub decisions</a:t>
+            </a:r>
+          </a:p>
+        </p:txBody>
+      </p:sp>
+      <p:sp>
+        <p:nvSpPr>
+          <p:cNvPr id="46" name="TextBox 45"/>
           <p:cNvSpPr txBox="1"/>
           <p:nvPr/>
         </p:nvSpPr>
         <p:spPr>
           <a:xfrm>
-            <a:off x="3383280" y="5102352"/>
-            <a:ext cx="2478024" cy="201168"/>
+            <a:off x="3383280" y="4937760"/>
+            <a:ext cx="2478024" cy="182880"/>
           </a:xfrm>
           <a:prstGeom prst="rect">
             <a:avLst/>
@@ -8505,21 +8811,21 @@
                 </a:solidFill>
                 <a:latin typeface="Calibri"/>
               </a:rPr>
-              <a:t>UAF-owned</a:t>
-            </a:r>
-          </a:p>
-        </p:txBody>
-      </p:sp>
-      <p:sp>
-        <p:nvSpPr>
-          <p:cNvPr id="46" name="Rounded Rectangle 45"/>
+              <a:t>UAF-controlled</a:t>
+            </a:r>
+          </a:p>
+        </p:txBody>
+      </p:sp>
+      <p:sp>
+        <p:nvSpPr>
+          <p:cNvPr id="47" name="Rounded Rectangle 46"/>
           <p:cNvSpPr/>
           <p:nvPr/>
         </p:nvSpPr>
         <p:spPr>
           <a:xfrm>
-            <a:off x="6135624" y="4160520"/>
-            <a:ext cx="2697480" cy="1234440"/>
+            <a:off x="6135624" y="4069080"/>
+            <a:ext cx="2697480" cy="1143000"/>
           </a:xfrm>
           <a:prstGeom prst="roundRect">
             <a:avLst>
@@ -8559,14 +8865,14 @@
       </p:sp>
       <p:sp>
         <p:nvSpPr>
-          <p:cNvPr id="47" name="TextBox 46"/>
+          <p:cNvPr id="48" name="TextBox 47"/>
           <p:cNvSpPr txBox="1"/>
           <p:nvPr/>
         </p:nvSpPr>
         <p:spPr>
           <a:xfrm>
-            <a:off x="6245352" y="4297680"/>
-            <a:ext cx="2478024" cy="256032"/>
+            <a:off x="6245352" y="4197096"/>
+            <a:ext cx="2478024" cy="237744"/>
           </a:xfrm>
           <a:prstGeom prst="rect">
             <a:avLst/>
@@ -8594,14 +8900,14 @@
       </p:sp>
       <p:sp>
         <p:nvSpPr>
-          <p:cNvPr id="48" name="TextBox 47"/>
+          <p:cNvPr id="49" name="TextBox 48"/>
           <p:cNvSpPr txBox="1"/>
           <p:nvPr/>
         </p:nvSpPr>
         <p:spPr>
           <a:xfrm>
-            <a:off x="6245352" y="4617720"/>
-            <a:ext cx="2478024" cy="411480"/>
+            <a:off x="6245352" y="4489704"/>
+            <a:ext cx="2478024" cy="457200"/>
           </a:xfrm>
           <a:prstGeom prst="rect">
             <a:avLst/>
@@ -8622,21 +8928,22 @@
                 </a:solidFill>
                 <a:latin typeface="Calibri"/>
               </a:rPr>
-              <a:t>Push · SMS · inbox</a:t>
-            </a:r>
-          </a:p>
-        </p:txBody>
-      </p:sp>
-      <p:sp>
-        <p:nvSpPr>
-          <p:cNvPr id="49" name="TextBox 48"/>
+              <a:t>Customer messaging
+Push · SMS · inbox</a:t>
+            </a:r>
+          </a:p>
+        </p:txBody>
+      </p:sp>
+      <p:sp>
+        <p:nvSpPr>
+          <p:cNvPr id="50" name="TextBox 49"/>
           <p:cNvSpPr txBox="1"/>
           <p:nvPr/>
         </p:nvSpPr>
         <p:spPr>
           <a:xfrm>
-            <a:off x="6245352" y="5102352"/>
-            <a:ext cx="2478024" cy="201168"/>
+            <a:off x="6245352" y="4937760"/>
+            <a:ext cx="2478024" cy="182880"/>
           </a:xfrm>
           <a:prstGeom prst="rect">
             <a:avLst/>
@@ -8657,21 +8964,21 @@
                 </a:solidFill>
                 <a:latin typeface="Calibri"/>
               </a:rPr>
-              <a:t>UAF-owned</a:t>
-            </a:r>
-          </a:p>
-        </p:txBody>
-      </p:sp>
-      <p:sp>
-        <p:nvSpPr>
-          <p:cNvPr id="50" name="Rounded Rectangle 49"/>
+              <a:t>UAF-controlled</a:t>
+            </a:r>
+          </a:p>
+        </p:txBody>
+      </p:sp>
+      <p:sp>
+        <p:nvSpPr>
+          <p:cNvPr id="51" name="Rounded Rectangle 50"/>
           <p:cNvSpPr/>
           <p:nvPr/>
         </p:nvSpPr>
         <p:spPr>
           <a:xfrm>
-            <a:off x="8997696" y="4160520"/>
-            <a:ext cx="2697480" cy="1234440"/>
+            <a:off x="8997696" y="4069080"/>
+            <a:ext cx="2697480" cy="1143000"/>
           </a:xfrm>
           <a:prstGeom prst="roundRect">
             <a:avLst>
@@ -8711,14 +9018,14 @@
       </p:sp>
       <p:sp>
         <p:nvSpPr>
-          <p:cNvPr id="51" name="TextBox 50"/>
+          <p:cNvPr id="52" name="TextBox 51"/>
           <p:cNvSpPr txBox="1"/>
           <p:nvPr/>
         </p:nvSpPr>
         <p:spPr>
           <a:xfrm>
-            <a:off x="9107424" y="4297680"/>
-            <a:ext cx="2478024" cy="256032"/>
+            <a:off x="9107424" y="4197096"/>
+            <a:ext cx="2478024" cy="237744"/>
           </a:xfrm>
           <a:prstGeom prst="rect">
             <a:avLst/>
@@ -8746,14 +9053,14 @@
       </p:sp>
       <p:sp>
         <p:nvSpPr>
-          <p:cNvPr id="52" name="TextBox 51"/>
+          <p:cNvPr id="53" name="TextBox 52"/>
           <p:cNvSpPr txBox="1"/>
           <p:nvPr/>
         </p:nvSpPr>
         <p:spPr>
           <a:xfrm>
-            <a:off x="9107424" y="4617720"/>
-            <a:ext cx="2478024" cy="411480"/>
+            <a:off x="9107424" y="4489704"/>
+            <a:ext cx="2478024" cy="457200"/>
           </a:xfrm>
           <a:prstGeom prst="rect">
             <a:avLst/>
@@ -8774,14 +9081,63 @@
                 </a:solidFill>
                 <a:latin typeface="Calibri"/>
               </a:rPr>
-              <a:t>Balances · Yes UA · sim surfaces</a:t>
+              <a:t>Customer &amp; channel APIs
+Yes UA · sim</a:t>
             </a:r>
           </a:p>
         </p:txBody>
       </p:sp>
       <p:pic>
         <p:nvPicPr>
-          <p:cNvPr id="53" name="Picture 52" descr="uaf_mark_32.png"/>
+          <p:cNvPr id="54" name="Picture 53" descr="uaf_mark_32.png"/>
+          <p:cNvPicPr>
+            <a:picLocks noChangeAspect="1"/>
+          </p:cNvPicPr>
+          <p:nvPr/>
+        </p:nvPicPr>
+        <p:blipFill>
+          <a:blip r:embed="rId3"/>
+          <a:stretch>
+            <a:fillRect/>
+          </a:stretch>
+        </p:blipFill>
+        <p:spPr>
+          <a:xfrm>
+            <a:off x="9107424" y="4882896"/>
+            <a:ext cx="219456" cy="219456"/>
+          </a:xfrm>
+          <a:prstGeom prst="rect">
+            <a:avLst/>
+          </a:prstGeom>
+        </p:spPr>
+      </p:pic>
+      <p:pic>
+        <p:nvPicPr>
+          <p:cNvPr id="55" name="Picture 54" descr="sim_mark_40.png"/>
+          <p:cNvPicPr>
+            <a:picLocks noChangeAspect="1"/>
+          </p:cNvPicPr>
+          <p:nvPr/>
+        </p:nvPicPr>
+        <p:blipFill>
+          <a:blip r:embed="rId4"/>
+          <a:stretch>
+            <a:fillRect/>
+          </a:stretch>
+        </p:blipFill>
+        <p:spPr>
+          <a:xfrm>
+            <a:off x="9363456" y="4882896"/>
+            <a:ext cx="219456" cy="219456"/>
+          </a:xfrm>
+          <a:prstGeom prst="rect">
+            <a:avLst/>
+          </a:prstGeom>
+        </p:spPr>
+      </p:pic>
+      <p:pic>
+        <p:nvPicPr>
+          <p:cNvPr id="56" name="Picture 55" descr="yesua_mark_40.png"/>
           <p:cNvPicPr>
             <a:picLocks noChangeAspect="1"/>
           </p:cNvPicPr>
@@ -8795,72 +9151,24 @@
         </p:blipFill>
         <p:spPr>
           <a:xfrm>
-            <a:off x="9107424" y="5029200"/>
-            <a:ext cx="237744" cy="237744"/>
+            <a:off x="9619488" y="4882896"/>
+            <a:ext cx="219456" cy="219456"/>
           </a:xfrm>
           <a:prstGeom prst="rect">
             <a:avLst/>
           </a:prstGeom>
         </p:spPr>
       </p:pic>
-      <p:pic>
-        <p:nvPicPr>
-          <p:cNvPr id="54" name="Picture 53" descr="sim_mark_40.png"/>
-          <p:cNvPicPr>
-            <a:picLocks noChangeAspect="1"/>
-          </p:cNvPicPr>
-          <p:nvPr/>
-        </p:nvPicPr>
-        <p:blipFill>
-          <a:blip r:embed="rId3"/>
-          <a:stretch>
-            <a:fillRect/>
-          </a:stretch>
-        </p:blipFill>
-        <p:spPr>
-          <a:xfrm>
-            <a:off x="9381744" y="5029200"/>
-            <a:ext cx="237744" cy="237744"/>
-          </a:xfrm>
-          <a:prstGeom prst="rect">
-            <a:avLst/>
-          </a:prstGeom>
-        </p:spPr>
-      </p:pic>
-      <p:pic>
-        <p:nvPicPr>
-          <p:cNvPr id="55" name="Picture 54" descr="yesua_mark_40.png"/>
-          <p:cNvPicPr>
-            <a:picLocks noChangeAspect="1"/>
-          </p:cNvPicPr>
-          <p:nvPr/>
-        </p:nvPicPr>
-        <p:blipFill>
-          <a:blip r:embed="rId6"/>
-          <a:stretch>
-            <a:fillRect/>
-          </a:stretch>
-        </p:blipFill>
-        <p:spPr>
-          <a:xfrm>
-            <a:off x="9656064" y="5029200"/>
-            <a:ext cx="237744" cy="237744"/>
-          </a:xfrm>
-          <a:prstGeom prst="rect">
-            <a:avLst/>
-          </a:prstGeom>
-        </p:spPr>
-      </p:pic>
-      <p:sp>
-        <p:nvSpPr>
-          <p:cNvPr id="56" name="Rounded Rectangle 55"/>
+      <p:sp>
+        <p:nvSpPr>
+          <p:cNvPr id="57" name="Rounded Rectangle 56"/>
           <p:cNvSpPr/>
           <p:nvPr/>
         </p:nvSpPr>
         <p:spPr>
           <a:xfrm>
-            <a:off x="411480" y="5532120"/>
-            <a:ext cx="2697480" cy="347472"/>
+            <a:off x="411480" y="5349240"/>
+            <a:ext cx="2697480" cy="320040"/>
           </a:xfrm>
           <a:prstGeom prst="roundRect">
             <a:avLst>
@@ -8900,13 +9208,13 @@
       </p:sp>
       <p:sp>
         <p:nvSpPr>
-          <p:cNvPr id="57" name="TextBox 56"/>
+          <p:cNvPr id="58" name="TextBox 57"/>
           <p:cNvSpPr txBox="1"/>
           <p:nvPr/>
         </p:nvSpPr>
         <p:spPr>
           <a:xfrm>
-            <a:off x="502920" y="5596128"/>
+            <a:off x="502920" y="5394960"/>
             <a:ext cx="2514600" cy="219456"/>
           </a:xfrm>
           <a:prstGeom prst="rect">
@@ -8928,21 +9236,21 @@
                 </a:solidFill>
                 <a:latin typeface="Calibri"/>
               </a:rPr>
-              <a:t>→ COD / coupon partners</a:t>
-            </a:r>
-          </a:p>
-        </p:txBody>
-      </p:sp>
-      <p:sp>
-        <p:nvSpPr>
-          <p:cNvPr id="58" name="Rounded Rectangle 57"/>
+              <a:t>→ COD / partners (our network)</a:t>
+            </a:r>
+          </a:p>
+        </p:txBody>
+      </p:sp>
+      <p:sp>
+        <p:nvSpPr>
+          <p:cNvPr id="59" name="Rounded Rectangle 58"/>
           <p:cNvSpPr/>
           <p:nvPr/>
         </p:nvSpPr>
         <p:spPr>
           <a:xfrm>
-            <a:off x="3273552" y="5532120"/>
-            <a:ext cx="8503920" cy="347472"/>
+            <a:off x="3273552" y="5349240"/>
+            <a:ext cx="8503920" cy="320040"/>
           </a:xfrm>
           <a:prstGeom prst="roundRect">
             <a:avLst>
@@ -8982,14 +9290,14 @@
       </p:sp>
       <p:sp>
         <p:nvSpPr>
-          <p:cNvPr id="59" name="TextBox 58"/>
+          <p:cNvPr id="60" name="TextBox 59"/>
           <p:cNvSpPr txBox="1"/>
           <p:nvPr/>
         </p:nvSpPr>
         <p:spPr>
           <a:xfrm>
-            <a:off x="3383280" y="5596128"/>
-            <a:ext cx="8229600" cy="219456"/>
+            <a:off x="3383280" y="5394960"/>
+            <a:ext cx="8686800" cy="219456"/>
           </a:xfrm>
           <a:prstGeom prst="rect">
             <a:avLst/>
@@ -9010,27 +9318,27 @@
                 </a:solidFill>
                 <a:latin typeface="Calibri"/>
               </a:rPr>
-              <a:t>Integration rule: LedgeRX connects only to the landing hub. CBP, gift, notify, XAPI are hub-side dependents.</a:t>
-            </a:r>
-          </a:p>
-        </p:txBody>
-      </p:sp>
-      <p:sp>
-        <p:nvSpPr>
-          <p:cNvPr id="60" name="Rectangle 59"/>
+              <a:t>Architecture rule we set: ledger capability never wires directly to fulfillment systems — hub is the control plane.</a:t>
+            </a:r>
+          </a:p>
+        </p:txBody>
+      </p:sp>
+      <p:sp>
+        <p:nvSpPr>
+          <p:cNvPr id="61" name="Rectangle 60"/>
           <p:cNvSpPr/>
           <p:nvPr/>
         </p:nvSpPr>
         <p:spPr>
           <a:xfrm>
-            <a:off x="0" y="6035040"/>
-            <a:ext cx="12191695" cy="822960"/>
+            <a:off x="0" y="5852160"/>
+            <a:ext cx="12191695" cy="1005840"/>
           </a:xfrm>
           <a:prstGeom prst="rect">
             <a:avLst/>
           </a:prstGeom>
           <a:solidFill>
-            <a:srgbClr val="FFFFFF"/>
+            <a:srgbClr val="EEF2F7"/>
           </a:solidFill>
           <a:ln>
             <a:noFill/>
@@ -9060,129 +9368,14 @@
       </p:sp>
       <p:sp>
         <p:nvSpPr>
-          <p:cNvPr id="61" name="Rectangle 60"/>
-          <p:cNvSpPr/>
-          <p:nvPr/>
-        </p:nvSpPr>
-        <p:spPr>
-          <a:xfrm>
-            <a:off x="0" y="6035040"/>
-            <a:ext cx="12191695" cy="18288"/>
-          </a:xfrm>
-          <a:prstGeom prst="rect">
-            <a:avLst/>
-          </a:prstGeom>
-          <a:solidFill>
-            <a:srgbClr val="D4D4D8"/>
-          </a:solidFill>
-          <a:ln>
-            <a:noFill/>
-          </a:ln>
-        </p:spPr>
-        <p:style>
-          <a:lnRef idx="1">
-            <a:schemeClr val="accent1"/>
-          </a:lnRef>
-          <a:fillRef idx="3">
-            <a:schemeClr val="accent1"/>
-          </a:fillRef>
-          <a:effectRef idx="2">
-            <a:schemeClr val="accent1"/>
-          </a:effectRef>
-          <a:fontRef idx="minor">
-            <a:schemeClr val="lt1"/>
-          </a:fontRef>
-        </p:style>
-        <p:txBody>
-          <a:bodyPr rtlCol="0" anchor="ctr"/>
-          <a:lstStyle/>
-          <a:p>
-            <a:pPr algn="ctr"/>
-          </a:p>
-        </p:txBody>
-      </p:sp>
-      <p:pic>
-        <p:nvPicPr>
-          <p:cNvPr id="62" name="Picture 61" descr="uaf_badge_48.png"/>
-          <p:cNvPicPr>
-            <a:picLocks noChangeAspect="1"/>
-          </p:cNvPicPr>
-          <p:nvPr/>
-        </p:nvPicPr>
-        <p:blipFill>
-          <a:blip r:embed="rId2"/>
-          <a:stretch>
-            <a:fillRect/>
-          </a:stretch>
-        </p:blipFill>
-        <p:spPr>
-          <a:xfrm>
-            <a:off x="457200" y="6199632"/>
-            <a:ext cx="1051560" cy="329184"/>
-          </a:xfrm>
-          <a:prstGeom prst="rect">
-            <a:avLst/>
-          </a:prstGeom>
-        </p:spPr>
-      </p:pic>
-      <p:pic>
-        <p:nvPicPr>
-          <p:cNvPr id="63" name="Picture 62" descr="sim_mark_40.png"/>
-          <p:cNvPicPr>
-            <a:picLocks noChangeAspect="1"/>
-          </p:cNvPicPr>
-          <p:nvPr/>
-        </p:nvPicPr>
-        <p:blipFill>
-          <a:blip r:embed="rId3"/>
-          <a:stretch>
-            <a:fillRect/>
-          </a:stretch>
-        </p:blipFill>
-        <p:spPr>
-          <a:xfrm>
-            <a:off x="1645920" y="6217920"/>
-            <a:ext cx="292608" cy="292608"/>
-          </a:xfrm>
-          <a:prstGeom prst="rect">
-            <a:avLst/>
-          </a:prstGeom>
-        </p:spPr>
-      </p:pic>
-      <p:pic>
-        <p:nvPicPr>
-          <p:cNvPr id="64" name="Picture 63" descr="yesua_mark_40.png"/>
-          <p:cNvPicPr>
-            <a:picLocks noChangeAspect="1"/>
-          </p:cNvPicPr>
-          <p:nvPr/>
-        </p:nvPicPr>
-        <p:blipFill>
-          <a:blip r:embed="rId6"/>
-          <a:stretch>
-            <a:fillRect/>
-          </a:stretch>
-        </p:blipFill>
-        <p:spPr>
-          <a:xfrm>
-            <a:off x="2011680" y="6217920"/>
-            <a:ext cx="292608" cy="292608"/>
-          </a:xfrm>
-          <a:prstGeom prst="rect">
-            <a:avLst/>
-          </a:prstGeom>
-        </p:spPr>
-      </p:pic>
-      <p:sp>
-        <p:nvSpPr>
-          <p:cNvPr id="65" name="TextBox 64"/>
+          <p:cNvPr id="62" name="TextBox 61"/>
           <p:cNvSpPr txBox="1"/>
           <p:nvPr/>
         </p:nvSpPr>
         <p:spPr>
           <a:xfrm>
-            <a:off x="2468880" y="6172200"/>
-            <a:ext cx="8686800" cy="457200"/>
+            <a:off x="411480" y="5989320"/>
+            <a:ext cx="11155680" cy="685800"/>
           </a:xfrm>
           <a:prstGeom prst="rect">
             <a:avLst/>
@@ -9197,49 +9390,16 @@
           <a:p>
             <a:pPr algn="l"/>
             <a:r>
-              <a:rPr sz="1100" b="0">
-                <a:solidFill>
-                  <a:srgbClr val="3F3F46"/>
+              <a:rPr sz="1200" b="0">
+                <a:solidFill>
+                  <a:srgbClr val="18181B"/>
                 </a:solidFill>
                 <a:latin typeface="Calibri"/>
               </a:rPr>
-              <a:t>Systems view — not a commercial pitch deck.
-LedgeRX = reward ledger provider  ·  UAF hub = only integration counterpart  ·  remaining boxes are internal UAF topology</a:t>
-            </a:r>
-          </a:p>
-        </p:txBody>
-      </p:sp>
-      <p:sp>
-        <p:nvSpPr>
-          <p:cNvPr id="66" name="TextBox 65"/>
-          <p:cNvSpPr txBox="1"/>
-          <p:nvPr/>
-        </p:nvSpPr>
-        <p:spPr>
-          <a:xfrm>
-            <a:off x="10515600" y="6309360"/>
-            <a:ext cx="1280160" cy="219456"/>
-          </a:xfrm>
-          <a:prstGeom prst="rect">
-            <a:avLst/>
-          </a:prstGeom>
-          <a:noFill/>
-        </p:spPr>
-        <p:txBody>
-          <a:bodyPr wrap="square" lIns="25400" rIns="25400" tIns="0" bIns="0">
-            <a:spAutoFit/>
-          </a:bodyPr>
-          <a:lstStyle/>
-          <a:p>
-            <a:pPr algn="r"/>
-            <a:r>
-              <a:rPr sz="1000" b="0">
-                <a:solidFill>
-                  <a:srgbClr val="71717A"/>
-                </a:solidFill>
-                <a:latin typeface="Calibri"/>
-              </a:rPr>
-              <a:t>Confidential</a:t>
+              <a:t>What we are proud of building
+1) A real domain split — channels / ledger / orchestration / fulfillment
+2) One controlled interface into rewards — not N brittle point-to-point links
+3) CBP and partners stay UAF assets; the ledger capability stays replaceable and focused</a:t>
             </a:r>
           </a:p>
         </p:txBody>

</xml_diff>